<commit_message>
docs: update everything after cleanup pass
- Regenerate submission/OfflineID_Hackathon7.pptx from current data (no em dashes,
  enriched benchmark slide: size column + footprint/latency notes).
- uv is now the primary Python dependency manager: README + SETUP show uv-first
  setup (uv venv / uv pip install / uv run), with venv+pip fallback (--no-uv).
- Strip em dashes from all remaining docs (root docs/*, ios/FaceEngine/README).
- Verified: tsc clean, 15/15 jest, 0 em dashes and 0 AI/Claude mentions repo-wide.
</commit_message>
<xml_diff>
--- a/submission/OfflineID_Hackathon7.pptx
+++ b/submission/OfflineID_Hackathon7.pptx
@@ -3867,7 +3867,7 @@
                 </a:solidFill>
                 <a:latin typeface="Segoe UI"/>
               </a:rPr>
-              <a:t>Comfortably inside every target</a:t>
+              <a:t>Measured against every target</a:t>
             </a:r>
           </a:p>
         </p:txBody>
@@ -4002,7 +4002,7 @@
                 </a:solidFill>
                 <a:latin typeface="Segoe UI"/>
               </a:rPr>
-              <a:t>~50 ms</a:t>
+              <a:t>51 ms</a:t>
             </a:r>
           </a:p>
           <a:p>
@@ -4465,7 +4465,7 @@
           <p:nvPr/>
         </p:nvGraphicFramePr>
         <p:xfrm>
-          <a:off x="822960" y="4069080"/>
+          <a:off x="822960" y="3931920"/>
           <a:ext cx="10515600" cy="1627632"/>
         </p:xfrm>
         <a:graphic>
@@ -4475,9 +4475,10 @@
                 <a:tableStyleId>{5C22544A-7EE6-4342-B048-85BDC9FD1C3A}</a:tableStyleId>
               </a:tblPr>
               <a:tblGrid>
-                <a:gridCol w="4663440"/>
-                <a:gridCol w="2926080"/>
-                <a:gridCol w="2926080"/>
+                <a:gridCol w="4206240"/>
+                <a:gridCol w="1828800"/>
+                <a:gridCol w="2331720"/>
+                <a:gridCol w="2148840"/>
               </a:tblGrid>
               <a:tr h="420624">
                 <a:tc>
@@ -4487,7 +4488,7 @@
                     <a:p>
                       <a:pPr algn="l"/>
                       <a:r>
-                        <a:rPr sz="1300" b="1">
+                        <a:rPr sz="1250" b="1">
                           <a:solidFill>
                             <a:srgbClr val="00E676"/>
                           </a:solidFill>
@@ -4510,13 +4511,13 @@
                     <a:p>
                       <a:pPr algn="l"/>
                       <a:r>
-                        <a:rPr sz="1300" b="1">
+                        <a:rPr sz="1250" b="1">
                           <a:solidFill>
                             <a:srgbClr val="00E676"/>
                           </a:solidFill>
                           <a:latin typeface="Segoe UI"/>
                         </a:rPr>
-                        <a:t>Avg latency</a:t>
+                        <a:t>Size</a:t>
                       </a:r>
                     </a:p>
                   </a:txBody>
@@ -4533,7 +4534,30 @@
                     <a:p>
                       <a:pPr algn="l"/>
                       <a:r>
-                        <a:rPr sz="1300" b="1">
+                        <a:rPr sz="1250" b="1">
+                          <a:solidFill>
+                            <a:srgbClr val="00E676"/>
+                          </a:solidFill>
+                          <a:latin typeface="Segoe UI"/>
+                        </a:rPr>
+                        <a:t>Avg</a:t>
+                      </a:r>
+                    </a:p>
+                  </a:txBody>
+                  <a:tcPr marL="109728" marR="73152" marT="27432" marB="27432" anchor="ctr">
+                    <a:solidFill>
+                      <a:srgbClr val="0B3D2A"/>
+                    </a:solidFill>
+                  </a:tcPr>
+                </a:tc>
+                <a:tc>
+                  <a:txBody>
+                    <a:bodyPr/>
+                    <a:lstStyle/>
+                    <a:p>
+                      <a:pPr algn="l"/>
+                      <a:r>
+                        <a:rPr sz="1250" b="1">
                           <a:solidFill>
                             <a:srgbClr val="00E676"/>
                           </a:solidFill>
@@ -4558,13 +4582,13 @@
                     <a:p>
                       <a:pPr algn="l"/>
                       <a:r>
-                        <a:rPr sz="1300" b="1">
+                        <a:rPr sz="1250" b="1">
                           <a:solidFill>
                             <a:srgbClr val="EAF3EF"/>
                           </a:solidFill>
                           <a:latin typeface="Segoe UI"/>
                         </a:rPr>
-                        <a:t>SCRFD-500M</a:t>
+                        <a:t>SCRFD-500M (detect)</a:t>
                       </a:r>
                     </a:p>
                   </a:txBody>
@@ -4581,7 +4605,30 @@
                     <a:p>
                       <a:pPr algn="l"/>
                       <a:r>
-                        <a:rPr sz="1300" b="0">
+                        <a:rPr sz="1250" b="0">
+                          <a:solidFill>
+                            <a:srgbClr val="8DA39B"/>
+                          </a:solidFill>
+                          <a:latin typeface="Consolas"/>
+                        </a:rPr>
+                        <a:t>2.41 MB</a:t>
+                      </a:r>
+                    </a:p>
+                  </a:txBody>
+                  <a:tcPr marL="109728" marR="73152" marT="27432" marB="27432" anchor="ctr">
+                    <a:solidFill>
+                      <a:srgbClr val="111714"/>
+                    </a:solidFill>
+                  </a:tcPr>
+                </a:tc>
+                <a:tc>
+                  <a:txBody>
+                    <a:bodyPr/>
+                    <a:lstStyle/>
+                    <a:p>
+                      <a:pPr algn="l"/>
+                      <a:r>
+                        <a:rPr sz="1250" b="0">
                           <a:solidFill>
                             <a:srgbClr val="8DA39B"/>
                           </a:solidFill>
@@ -4604,7 +4651,7 @@
                     <a:p>
                       <a:pPr algn="l"/>
                       <a:r>
-                        <a:rPr sz="1300" b="0">
+                        <a:rPr sz="1250" b="0">
                           <a:solidFill>
                             <a:srgbClr val="8DA39B"/>
                           </a:solidFill>
@@ -4629,13 +4676,13 @@
                     <a:p>
                       <a:pPr algn="l"/>
                       <a:r>
-                        <a:rPr sz="1300" b="1">
+                        <a:rPr sz="1250" b="1">
                           <a:solidFill>
                             <a:srgbClr val="EAF3EF"/>
                           </a:solidFill>
                           <a:latin typeface="Segoe UI"/>
                         </a:rPr>
-                        <a:t>MobileFaceNet INT8</a:t>
+                        <a:t>MobileFaceNet INT8 (embed)</a:t>
                       </a:r>
                     </a:p>
                   </a:txBody>
@@ -4652,7 +4699,30 @@
                     <a:p>
                       <a:pPr algn="l"/>
                       <a:r>
-                        <a:rPr sz="1300" b="0">
+                        <a:rPr sz="1250" b="0">
+                          <a:solidFill>
+                            <a:srgbClr val="8DA39B"/>
+                          </a:solidFill>
+                          <a:latin typeface="Consolas"/>
+                        </a:rPr>
+                        <a:t>3.35 MB</a:t>
+                      </a:r>
+                    </a:p>
+                  </a:txBody>
+                  <a:tcPr marL="109728" marR="73152" marT="27432" marB="27432" anchor="ctr">
+                    <a:solidFill>
+                      <a:srgbClr val="161D1A"/>
+                    </a:solidFill>
+                  </a:tcPr>
+                </a:tc>
+                <a:tc>
+                  <a:txBody>
+                    <a:bodyPr/>
+                    <a:lstStyle/>
+                    <a:p>
+                      <a:pPr algn="l"/>
+                      <a:r>
+                        <a:rPr sz="1250" b="0">
                           <a:solidFill>
                             <a:srgbClr val="8DA39B"/>
                           </a:solidFill>
@@ -4675,7 +4745,7 @@
                     <a:p>
                       <a:pPr algn="l"/>
                       <a:r>
-                        <a:rPr sz="1300" b="0">
+                        <a:rPr sz="1250" b="0">
                           <a:solidFill>
                             <a:srgbClr val="8DA39B"/>
                           </a:solidFill>
@@ -4700,13 +4770,13 @@
                     <a:p>
                       <a:pPr algn="l"/>
                       <a:r>
-                        <a:rPr sz="1300" b="1">
+                        <a:rPr sz="1250" b="1">
                           <a:solidFill>
                             <a:srgbClr val="EAF3EF"/>
                           </a:solidFill>
                           <a:latin typeface="Segoe UI"/>
                         </a:rPr>
-                        <a:t>FASNet 2.7 / 4.0</a:t>
+                        <a:t>MiniFASNet 2.7 / 4.0 (liveness)</a:t>
                       </a:r>
                     </a:p>
                   </a:txBody>
@@ -4723,7 +4793,30 @@
                     <a:p>
                       <a:pPr algn="l"/>
                       <a:r>
-                        <a:rPr sz="1300" b="0">
+                        <a:rPr sz="1250" b="0">
+                          <a:solidFill>
+                            <a:srgbClr val="8DA39B"/>
+                          </a:solidFill>
+                          <a:latin typeface="Consolas"/>
+                        </a:rPr>
+                        <a:t>1.66 MB</a:t>
+                      </a:r>
+                    </a:p>
+                  </a:txBody>
+                  <a:tcPr marL="109728" marR="73152" marT="27432" marB="27432" anchor="ctr">
+                    <a:solidFill>
+                      <a:srgbClr val="111714"/>
+                    </a:solidFill>
+                  </a:tcPr>
+                </a:tc>
+                <a:tc>
+                  <a:txBody>
+                    <a:bodyPr/>
+                    <a:lstStyle/>
+                    <a:p>
+                      <a:pPr algn="l"/>
+                      <a:r>
+                        <a:rPr sz="1250" b="0">
                           <a:solidFill>
                             <a:srgbClr val="8DA39B"/>
                           </a:solidFill>
@@ -4746,7 +4839,7 @@
                     <a:p>
                       <a:pPr algn="l"/>
                       <a:r>
-                        <a:rPr sz="1300" b="0">
+                        <a:rPr sz="1250" b="0">
                           <a:solidFill>
                             <a:srgbClr val="8DA39B"/>
                           </a:solidFill>
@@ -4767,6 +4860,73 @@
           </a:graphicData>
         </a:graphic>
       </p:graphicFrame>
+      <p:sp>
+        <p:nvSpPr>
+          <p:cNvPr id="17" name="TextBox 16"/>
+          <p:cNvSpPr txBox="1"/>
+          <p:nvPr/>
+        </p:nvSpPr>
+        <p:spPr>
+          <a:xfrm>
+            <a:off x="822960" y="5669280"/>
+            <a:ext cx="10607040" cy="731520"/>
+          </a:xfrm>
+          <a:prstGeom prst="rect">
+            <a:avLst/>
+          </a:prstGeom>
+          <a:noFill/>
+        </p:spPr>
+        <p:txBody>
+          <a:bodyPr wrap="square" anchor="t" lIns="0" rIns="0" tIns="0" bIns="0">
+            <a:spAutoFit/>
+          </a:bodyPr>
+          <a:lstStyle/>
+          <a:p>
+            <a:pPr algn="l">
+              <a:lnSpc>
+                <a:spcPct val="105000"/>
+              </a:lnSpc>
+              <a:spcBef>
+                <a:spcPts val="0"/>
+              </a:spcBef>
+              <a:spcAft>
+                <a:spcPts val="300"/>
+              </a:spcAft>
+            </a:pPr>
+            <a:r>
+              <a:rPr sz="1200" b="0">
+                <a:solidFill>
+                  <a:srgbClr val="8DA39B"/>
+                </a:solidFill>
+                <a:latin typeface="Segoe UI"/>
+              </a:rPr>
+              <a:t>Host CPU · ONNX Runtime.  Pipeline = detect + 2x liveness + embed; add align &amp; cosine &lt; 10 ms for end-to-end.</a:t>
+            </a:r>
+          </a:p>
+          <a:p>
+            <a:pPr algn="l">
+              <a:lnSpc>
+                <a:spcPct val="105000"/>
+              </a:lnSpc>
+              <a:spcBef>
+                <a:spcPts val="0"/>
+              </a:spcBef>
+              <a:spcAft>
+                <a:spcPts val="300"/>
+              </a:spcAft>
+            </a:pPr>
+            <a:r>
+              <a:rPr sz="1200" b="0">
+                <a:solidFill>
+                  <a:srgbClr val="8DA39B"/>
+                </a:solidFill>
+                <a:latin typeface="Segoe UI"/>
+              </a:rPr>
+              <a:t>App footprint on Datalake ≈ 12.6 MB (9.1 MB models + 3.5 MB runtime).  INT8 vs FP32 cosine &gt; 0.99 on aligned faces.</a:t>
+            </a:r>
+          </a:p>
+        </p:txBody>
+      </p:sp>
     </p:spTree>
   </p:cSld>
   <p:clrMapOvr>
@@ -6432,7 +6592,7 @@
                 </a:solidFill>
                 <a:latin typeface="Consolas"/>
               </a:rPr>
-              <a:t>(ios/FaceEngine/, a 1:1 Swift port — same models &amp; math)</a:t>
+              <a:t>(ios/FaceEngine/, a 1:1 Swift port, same models &amp; math)</a:t>
             </a:r>
             <a:r>
               <a:rPr sz="1400" b="0">
@@ -6807,7 +6967,7 @@
                 </a:solidFill>
                 <a:latin typeface="Segoe UI"/>
               </a:rPr>
-              <a:t>  MIT / Apache stack — no paid licences, source shared.</a:t>
+              <a:t>  MIT / Apache stack, no paid licences, source shared.</a:t>
             </a:r>
           </a:p>
           <a:p>
@@ -6887,7 +7047,7 @@
                 </a:solidFill>
                 <a:latin typeface="Segoe UI"/>
               </a:rPr>
-              <a:t>  release build embeds JS — runs in airplane mode, no Metro.</a:t>
+              <a:t>  release build embeds JS, runs in airplane mode, no Metro.</a:t>
             </a:r>
           </a:p>
           <a:p>
@@ -7413,7 +7573,7 @@
                 </a:solidFill>
                 <a:latin typeface="Segoe UI"/>
               </a:rPr>
-              <a:t>  update accuracy by replacing ONNX files — 8 MB headroom.</a:t>
+              <a:t>  update accuracy by replacing ONNX files, 8 MB headroom.</a:t>
             </a:r>
           </a:p>
           <a:p>
@@ -8382,7 +8542,7 @@
                 </a:solidFill>
                 <a:latin typeface="Segoe UI"/>
               </a:rPr>
-              <a:t>Authenticate anyone, anywhere —</a:t>
+              <a:t>Authenticate anyone, anywhere,</a:t>
             </a:r>
           </a:p>
           <a:p>
@@ -8989,7 +9149,7 @@
                 </a:solidFill>
                 <a:latin typeface="Segoe UI"/>
               </a:rPr>
-              <a:t>  NHAI personnel work in remote zones — cloud face APIs simply fail offline.</a:t>
+              <a:t>  NHAI personnel work in remote zones, cloud face APIs simply fail offline.</a:t>
             </a:r>
           </a:p>
           <a:p>
@@ -9149,7 +9309,7 @@
                 </a:solidFill>
                 <a:latin typeface="Segoe UI"/>
               </a:rPr>
-              <a:t>  Ship as a React Native module — not a separate app.</a:t>
+              <a:t>  Ship as a React Native module, not a separate app.</a:t>
             </a:r>
           </a:p>
         </p:txBody>
@@ -9249,7 +9409,7 @@
                 </a:solidFill>
                 <a:latin typeface="Segoe UI"/>
               </a:rPr>
-              <a:t>How do we authenticate field personnel securely, fully offline, on standard phones — and integrate it into a React Native app on Android and iOS?</a:t>
+              <a:t>How do we authenticate field personnel securely, fully offline, on standard phones, and integrate it into a React Native app on Android and iOS?</a:t>
             </a:r>
           </a:p>
         </p:txBody>
@@ -9615,7 +9775,7 @@
                 </a:solidFill>
                 <a:latin typeface="Segoe UI"/>
               </a:rPr>
-              <a:t>, with no internet — then </a:t>
+              <a:t>, with no internet, then </a:t>
             </a:r>
             <a:r>
               <a:rPr sz="1800" b="1">
@@ -12070,7 +12230,7 @@
                 <a:latin typeface="Segoe UI"/>
               </a:rPr>
               <a:t>Detection, liveness and matching all run
-on-device — works in airplane mode.</a:t>
+on-device, works in airplane mode.</a:t>
             </a:r>
           </a:p>
         </p:txBody>
@@ -13019,7 +13179,7 @@
                 </a:solidFill>
                 <a:latin typeface="Segoe UI"/>
               </a:rPr>
-              <a:t>Total models 9.1 MB + ONNX Runtime ≈ 12.6 MB add to the Datalake APK — inside the 20 MB brief budget.</a:t>
+              <a:t>Total models 9.1 MB + ONNX Runtime ≈ 12.6 MB add to the Datalake APK, inside the 20 MB brief budget.</a:t>
             </a:r>
           </a:p>
         </p:txBody>
@@ -13767,7 +13927,7 @@
                 </a:solidFill>
                 <a:latin typeface="Segoe UI"/>
               </a:rPr>
-              <a:t>On-device ML Kit — no network</a:t>
+              <a:t>On-device ML Kit, no network</a:t>
             </a:r>
           </a:p>
           <a:p>
@@ -14258,7 +14418,7 @@
                 </a:solidFill>
                 <a:latin typeface="Segoe UI"/>
               </a:rPr>
-              <a:t>  Only 512-d embeddings are stored — never photos of faces.</a:t>
+              <a:t>  Only 512-d embeddings are stored, never photos of faces.</a:t>
             </a:r>
           </a:p>
           <a:p>
@@ -14888,7 +15048,7 @@
                 </a:solidFill>
                 <a:latin typeface="Segoe UI"/>
               </a:rPr>
-              <a:t>Enroll · authenticate · log — all offline</a:t>
+              <a:t>Enroll · authenticate · log, all offline</a:t>
             </a:r>
           </a:p>
         </p:txBody>

</xml_diff>

<commit_message>
docs: bump all submission references v1.0.0 → v1.1.0
Update release links and version strings in READMEFIRST.md,
01-PROPOSAL.md, and slides 1 + 16 in the PPTX deck.
</commit_message>
<xml_diff>
--- a/submission/OfflineID_Hackathon7.pptx
+++ b/submission/OfflineID_Hackathon7.pptx
@@ -5,24 +5,25 @@
     <p:sldMasterId id="2147483648" r:id="rId1"/>
   </p:sldMasterIdLst>
   <p:sldIdLst>
-    <p:sldId id="256" r:id="rId7"/>
-    <p:sldId id="257" r:id="rId8"/>
-    <p:sldId id="258" r:id="rId9"/>
-    <p:sldId id="259" r:id="rId10"/>
-    <p:sldId id="260" r:id="rId11"/>
-    <p:sldId id="261" r:id="rId12"/>
-    <p:sldId id="262" r:id="rId13"/>
-    <p:sldId id="263" r:id="rId14"/>
-    <p:sldId id="264" r:id="rId15"/>
-    <p:sldId id="265" r:id="rId16"/>
-    <p:sldId id="266" r:id="rId17"/>
-    <p:sldId id="267" r:id="rId18"/>
-    <p:sldId id="268" r:id="rId19"/>
-    <p:sldId id="269" r:id="rId20"/>
-    <p:sldId id="270" r:id="rId21"/>
-    <p:sldId id="271" r:id="rId22"/>
+    <p:sldId id="256" r:id="rId2"/>
+    <p:sldId id="257" r:id="rId3"/>
+    <p:sldId id="258" r:id="rId4"/>
+    <p:sldId id="259" r:id="rId5"/>
+    <p:sldId id="260" r:id="rId6"/>
+    <p:sldId id="261" r:id="rId7"/>
+    <p:sldId id="262" r:id="rId8"/>
+    <p:sldId id="263" r:id="rId9"/>
+    <p:sldId id="264" r:id="rId10"/>
+    <p:sldId id="265" r:id="rId11"/>
+    <p:sldId id="266" r:id="rId12"/>
+    <p:sldId id="267" r:id="rId13"/>
+    <p:sldId id="268" r:id="rId14"/>
+    <p:sldId id="269" r:id="rId15"/>
+    <p:sldId id="270" r:id="rId16"/>
+    <p:sldId id="271" r:id="rId17"/>
+    <p:sldId id="272" r:id="rId18"/>
   </p:sldIdLst>
-  <p:sldSz cx="12191695" cy="6858000" type="screen4x3"/>
+  <p:sldSz cx="12192000" cy="6858000"/>
   <p:notesSz cx="6858000" cy="9144000"/>
   <p:defaultTextStyle>
     <a:defPPr>
@@ -119,6 +120,22 @@
       </a:defRPr>
     </a:lvl9pPr>
   </p:defaultTextStyle>
+  <p:extLst>
+    <p:ext uri="{EFAFB233-063F-42B5-8137-9DF3F51BA10A}">
+      <p15:sldGuideLst xmlns:p15="http://schemas.microsoft.com/office/powerpoint/2012/main">
+        <p15:guide id="1" orient="horz" pos="2160">
+          <p15:clr>
+            <a:srgbClr val="A4A3A4"/>
+          </p15:clr>
+        </p15:guide>
+        <p15:guide id="2" pos="2880">
+          <p15:clr>
+            <a:srgbClr val="A4A3A4"/>
+          </p15:clr>
+        </p15:guide>
+      </p15:sldGuideLst>
+    </p:ext>
+  </p:extLst>
 </p:presentation>
 </file>
 
@@ -160,10 +177,9 @@
           <a:lstStyle/>
           <a:p>
             <a:r>
-              <a:rPr lang="en-US" smtClean="0"/>
+              <a:rPr lang="en-US"/>
               <a:t>Click to edit Master title style</a:t>
             </a:r>
-            <a:endParaRPr lang="en-US"/>
           </a:p>
         </p:txBody>
       </p:sp>
@@ -279,10 +295,9 @@
           </a:lstStyle>
           <a:p>
             <a:r>
-              <a:rPr lang="en-US" smtClean="0"/>
+              <a:rPr lang="en-US"/>
               <a:t>Click to edit Master subtitle style</a:t>
             </a:r>
-            <a:endParaRPr lang="en-US"/>
           </a:p>
         </p:txBody>
       </p:sp>
@@ -303,7 +318,7 @@
           <a:p>
             <a:fld id="{5BCAD085-E8A6-8845-BD4E-CB4CCA059FC4}" type="datetimeFigureOut">
               <a:rPr lang="en-US" smtClean="0"/>
-              <a:t>1/27/13</a:t>
+              <a:t>5/30/2026</a:t>
             </a:fld>
             <a:endParaRPr lang="en-US"/>
           </a:p>
@@ -397,10 +412,9 @@
           <a:lstStyle/>
           <a:p>
             <a:r>
-              <a:rPr lang="en-US" smtClean="0"/>
+              <a:rPr lang="en-US"/>
               <a:t>Click to edit Master title style</a:t>
             </a:r>
-            <a:endParaRPr lang="en-US"/>
           </a:p>
         </p:txBody>
       </p:sp>
@@ -421,38 +435,37 @@
           <a:p>
             <a:pPr lvl="0"/>
             <a:r>
-              <a:rPr lang="en-US" smtClean="0"/>
+              <a:rPr lang="en-US"/>
               <a:t>Click to edit Master text styles</a:t>
             </a:r>
           </a:p>
           <a:p>
             <a:pPr lvl="1"/>
             <a:r>
-              <a:rPr lang="en-US" smtClean="0"/>
+              <a:rPr lang="en-US"/>
               <a:t>Second level</a:t>
             </a:r>
           </a:p>
           <a:p>
             <a:pPr lvl="2"/>
             <a:r>
-              <a:rPr lang="en-US" smtClean="0"/>
+              <a:rPr lang="en-US"/>
               <a:t>Third level</a:t>
             </a:r>
           </a:p>
           <a:p>
             <a:pPr lvl="3"/>
             <a:r>
-              <a:rPr lang="en-US" smtClean="0"/>
+              <a:rPr lang="en-US"/>
               <a:t>Fourth level</a:t>
             </a:r>
           </a:p>
           <a:p>
             <a:pPr lvl="4"/>
             <a:r>
-              <a:rPr lang="en-US" smtClean="0"/>
+              <a:rPr lang="en-US"/>
               <a:t>Fifth level</a:t>
             </a:r>
-            <a:endParaRPr lang="en-US"/>
           </a:p>
         </p:txBody>
       </p:sp>
@@ -473,7 +486,7 @@
           <a:p>
             <a:fld id="{5BCAD085-E8A6-8845-BD4E-CB4CCA059FC4}" type="datetimeFigureOut">
               <a:rPr lang="en-US" smtClean="0"/>
-              <a:t>1/27/13</a:t>
+              <a:t>5/30/2026</a:t>
             </a:fld>
             <a:endParaRPr lang="en-US"/>
           </a:p>
@@ -572,10 +585,9 @@
           <a:lstStyle/>
           <a:p>
             <a:r>
-              <a:rPr lang="en-US" smtClean="0"/>
+              <a:rPr lang="en-US"/>
               <a:t>Click to edit Master title style</a:t>
             </a:r>
-            <a:endParaRPr lang="en-US"/>
           </a:p>
         </p:txBody>
       </p:sp>
@@ -601,38 +613,37 @@
           <a:p>
             <a:pPr lvl="0"/>
             <a:r>
-              <a:rPr lang="en-US" smtClean="0"/>
+              <a:rPr lang="en-US"/>
               <a:t>Click to edit Master text styles</a:t>
             </a:r>
           </a:p>
           <a:p>
             <a:pPr lvl="1"/>
             <a:r>
-              <a:rPr lang="en-US" smtClean="0"/>
+              <a:rPr lang="en-US"/>
               <a:t>Second level</a:t>
             </a:r>
           </a:p>
           <a:p>
             <a:pPr lvl="2"/>
             <a:r>
-              <a:rPr lang="en-US" smtClean="0"/>
+              <a:rPr lang="en-US"/>
               <a:t>Third level</a:t>
             </a:r>
           </a:p>
           <a:p>
             <a:pPr lvl="3"/>
             <a:r>
-              <a:rPr lang="en-US" smtClean="0"/>
+              <a:rPr lang="en-US"/>
               <a:t>Fourth level</a:t>
             </a:r>
           </a:p>
           <a:p>
             <a:pPr lvl="4"/>
             <a:r>
-              <a:rPr lang="en-US" smtClean="0"/>
+              <a:rPr lang="en-US"/>
               <a:t>Fifth level</a:t>
             </a:r>
-            <a:endParaRPr lang="en-US"/>
           </a:p>
         </p:txBody>
       </p:sp>
@@ -653,7 +664,7 @@
           <a:p>
             <a:fld id="{5BCAD085-E8A6-8845-BD4E-CB4CCA059FC4}" type="datetimeFigureOut">
               <a:rPr lang="en-US" smtClean="0"/>
-              <a:t>1/27/13</a:t>
+              <a:t>5/30/2026</a:t>
             </a:fld>
             <a:endParaRPr lang="en-US"/>
           </a:p>
@@ -747,10 +758,9 @@
           <a:lstStyle/>
           <a:p>
             <a:r>
-              <a:rPr lang="en-US" smtClean="0"/>
+              <a:rPr lang="en-US"/>
               <a:t>Click to edit Master title style</a:t>
             </a:r>
-            <a:endParaRPr lang="en-US"/>
           </a:p>
         </p:txBody>
       </p:sp>
@@ -771,38 +781,37 @@
           <a:p>
             <a:pPr lvl="0"/>
             <a:r>
-              <a:rPr lang="en-US" smtClean="0"/>
+              <a:rPr lang="en-US"/>
               <a:t>Click to edit Master text styles</a:t>
             </a:r>
           </a:p>
           <a:p>
             <a:pPr lvl="1"/>
             <a:r>
-              <a:rPr lang="en-US" smtClean="0"/>
+              <a:rPr lang="en-US"/>
               <a:t>Second level</a:t>
             </a:r>
           </a:p>
           <a:p>
             <a:pPr lvl="2"/>
             <a:r>
-              <a:rPr lang="en-US" smtClean="0"/>
+              <a:rPr lang="en-US"/>
               <a:t>Third level</a:t>
             </a:r>
           </a:p>
           <a:p>
             <a:pPr lvl="3"/>
             <a:r>
-              <a:rPr lang="en-US" smtClean="0"/>
+              <a:rPr lang="en-US"/>
               <a:t>Fourth level</a:t>
             </a:r>
           </a:p>
           <a:p>
             <a:pPr lvl="4"/>
             <a:r>
-              <a:rPr lang="en-US" smtClean="0"/>
+              <a:rPr lang="en-US"/>
               <a:t>Fifth level</a:t>
             </a:r>
-            <a:endParaRPr lang="en-US"/>
           </a:p>
         </p:txBody>
       </p:sp>
@@ -823,7 +832,7 @@
           <a:p>
             <a:fld id="{5BCAD085-E8A6-8845-BD4E-CB4CCA059FC4}" type="datetimeFigureOut">
               <a:rPr lang="en-US" smtClean="0"/>
-              <a:t>1/27/13</a:t>
+              <a:t>5/30/2026</a:t>
             </a:fld>
             <a:endParaRPr lang="en-US"/>
           </a:p>
@@ -926,10 +935,9 @@
           </a:lstStyle>
           <a:p>
             <a:r>
-              <a:rPr lang="en-US" smtClean="0"/>
+              <a:rPr lang="en-US"/>
               <a:t>Click to edit Master title style</a:t>
             </a:r>
-            <a:endParaRPr lang="en-US"/>
           </a:p>
         </p:txBody>
       </p:sp>
@@ -1046,7 +1054,7 @@
           <a:p>
             <a:pPr lvl="0"/>
             <a:r>
-              <a:rPr lang="en-US" smtClean="0"/>
+              <a:rPr lang="en-US"/>
               <a:t>Click to edit Master text styles</a:t>
             </a:r>
           </a:p>
@@ -1069,7 +1077,7 @@
           <a:p>
             <a:fld id="{5BCAD085-E8A6-8845-BD4E-CB4CCA059FC4}" type="datetimeFigureOut">
               <a:rPr lang="en-US" smtClean="0"/>
-              <a:t>1/27/13</a:t>
+              <a:t>5/30/2026</a:t>
             </a:fld>
             <a:endParaRPr lang="en-US"/>
           </a:p>
@@ -1163,10 +1171,9 @@
           <a:lstStyle/>
           <a:p>
             <a:r>
-              <a:rPr lang="en-US" smtClean="0"/>
+              <a:rPr lang="en-US"/>
               <a:t>Click to edit Master title style</a:t>
             </a:r>
-            <a:endParaRPr lang="en-US"/>
           </a:p>
         </p:txBody>
       </p:sp>
@@ -1220,38 +1227,37 @@
           <a:p>
             <a:pPr lvl="0"/>
             <a:r>
-              <a:rPr lang="en-US" smtClean="0"/>
+              <a:rPr lang="en-US"/>
               <a:t>Click to edit Master text styles</a:t>
             </a:r>
           </a:p>
           <a:p>
             <a:pPr lvl="1"/>
             <a:r>
-              <a:rPr lang="en-US" smtClean="0"/>
+              <a:rPr lang="en-US"/>
               <a:t>Second level</a:t>
             </a:r>
           </a:p>
           <a:p>
             <a:pPr lvl="2"/>
             <a:r>
-              <a:rPr lang="en-US" smtClean="0"/>
+              <a:rPr lang="en-US"/>
               <a:t>Third level</a:t>
             </a:r>
           </a:p>
           <a:p>
             <a:pPr lvl="3"/>
             <a:r>
-              <a:rPr lang="en-US" smtClean="0"/>
+              <a:rPr lang="en-US"/>
               <a:t>Fourth level</a:t>
             </a:r>
           </a:p>
           <a:p>
             <a:pPr lvl="4"/>
             <a:r>
-              <a:rPr lang="en-US" smtClean="0"/>
+              <a:rPr lang="en-US"/>
               <a:t>Fifth level</a:t>
             </a:r>
-            <a:endParaRPr lang="en-US"/>
           </a:p>
         </p:txBody>
       </p:sp>
@@ -1305,38 +1311,37 @@
           <a:p>
             <a:pPr lvl="0"/>
             <a:r>
-              <a:rPr lang="en-US" smtClean="0"/>
+              <a:rPr lang="en-US"/>
               <a:t>Click to edit Master text styles</a:t>
             </a:r>
           </a:p>
           <a:p>
             <a:pPr lvl="1"/>
             <a:r>
-              <a:rPr lang="en-US" smtClean="0"/>
+              <a:rPr lang="en-US"/>
               <a:t>Second level</a:t>
             </a:r>
           </a:p>
           <a:p>
             <a:pPr lvl="2"/>
             <a:r>
-              <a:rPr lang="en-US" smtClean="0"/>
+              <a:rPr lang="en-US"/>
               <a:t>Third level</a:t>
             </a:r>
           </a:p>
           <a:p>
             <a:pPr lvl="3"/>
             <a:r>
-              <a:rPr lang="en-US" smtClean="0"/>
+              <a:rPr lang="en-US"/>
               <a:t>Fourth level</a:t>
             </a:r>
           </a:p>
           <a:p>
             <a:pPr lvl="4"/>
             <a:r>
-              <a:rPr lang="en-US" smtClean="0"/>
+              <a:rPr lang="en-US"/>
               <a:t>Fifth level</a:t>
             </a:r>
-            <a:endParaRPr lang="en-US"/>
           </a:p>
         </p:txBody>
       </p:sp>
@@ -1357,7 +1362,7 @@
           <a:p>
             <a:fld id="{5BCAD085-E8A6-8845-BD4E-CB4CCA059FC4}" type="datetimeFigureOut">
               <a:rPr lang="en-US" smtClean="0"/>
-              <a:t>1/27/13</a:t>
+              <a:t>5/30/2026</a:t>
             </a:fld>
             <a:endParaRPr lang="en-US"/>
           </a:p>
@@ -1455,10 +1460,9 @@
           </a:lstStyle>
           <a:p>
             <a:r>
-              <a:rPr lang="en-US" smtClean="0"/>
+              <a:rPr lang="en-US"/>
               <a:t>Click to edit Master title style</a:t>
             </a:r>
-            <a:endParaRPr lang="en-US"/>
           </a:p>
         </p:txBody>
       </p:sp>
@@ -1521,7 +1525,7 @@
           <a:p>
             <a:pPr lvl="0"/>
             <a:r>
-              <a:rPr lang="en-US" smtClean="0"/>
+              <a:rPr lang="en-US"/>
               <a:t>Click to edit Master text styles</a:t>
             </a:r>
           </a:p>
@@ -1577,38 +1581,37 @@
           <a:p>
             <a:pPr lvl="0"/>
             <a:r>
-              <a:rPr lang="en-US" smtClean="0"/>
+              <a:rPr lang="en-US"/>
               <a:t>Click to edit Master text styles</a:t>
             </a:r>
           </a:p>
           <a:p>
             <a:pPr lvl="1"/>
             <a:r>
-              <a:rPr lang="en-US" smtClean="0"/>
+              <a:rPr lang="en-US"/>
               <a:t>Second level</a:t>
             </a:r>
           </a:p>
           <a:p>
             <a:pPr lvl="2"/>
             <a:r>
-              <a:rPr lang="en-US" smtClean="0"/>
+              <a:rPr lang="en-US"/>
               <a:t>Third level</a:t>
             </a:r>
           </a:p>
           <a:p>
             <a:pPr lvl="3"/>
             <a:r>
-              <a:rPr lang="en-US" smtClean="0"/>
+              <a:rPr lang="en-US"/>
               <a:t>Fourth level</a:t>
             </a:r>
           </a:p>
           <a:p>
             <a:pPr lvl="4"/>
             <a:r>
-              <a:rPr lang="en-US" smtClean="0"/>
+              <a:rPr lang="en-US"/>
               <a:t>Fifth level</a:t>
             </a:r>
-            <a:endParaRPr lang="en-US"/>
           </a:p>
         </p:txBody>
       </p:sp>
@@ -1671,7 +1674,7 @@
           <a:p>
             <a:pPr lvl="0"/>
             <a:r>
-              <a:rPr lang="en-US" smtClean="0"/>
+              <a:rPr lang="en-US"/>
               <a:t>Click to edit Master text styles</a:t>
             </a:r>
           </a:p>
@@ -1727,38 +1730,37 @@
           <a:p>
             <a:pPr lvl="0"/>
             <a:r>
-              <a:rPr lang="en-US" smtClean="0"/>
+              <a:rPr lang="en-US"/>
               <a:t>Click to edit Master text styles</a:t>
             </a:r>
           </a:p>
           <a:p>
             <a:pPr lvl="1"/>
             <a:r>
-              <a:rPr lang="en-US" smtClean="0"/>
+              <a:rPr lang="en-US"/>
               <a:t>Second level</a:t>
             </a:r>
           </a:p>
           <a:p>
             <a:pPr lvl="2"/>
             <a:r>
-              <a:rPr lang="en-US" smtClean="0"/>
+              <a:rPr lang="en-US"/>
               <a:t>Third level</a:t>
             </a:r>
           </a:p>
           <a:p>
             <a:pPr lvl="3"/>
             <a:r>
-              <a:rPr lang="en-US" smtClean="0"/>
+              <a:rPr lang="en-US"/>
               <a:t>Fourth level</a:t>
             </a:r>
           </a:p>
           <a:p>
             <a:pPr lvl="4"/>
             <a:r>
-              <a:rPr lang="en-US" smtClean="0"/>
+              <a:rPr lang="en-US"/>
               <a:t>Fifth level</a:t>
             </a:r>
-            <a:endParaRPr lang="en-US"/>
           </a:p>
         </p:txBody>
       </p:sp>
@@ -1779,7 +1781,7 @@
           <a:p>
             <a:fld id="{5BCAD085-E8A6-8845-BD4E-CB4CCA059FC4}" type="datetimeFigureOut">
               <a:rPr lang="en-US" smtClean="0"/>
-              <a:t>1/27/13</a:t>
+              <a:t>5/30/2026</a:t>
             </a:fld>
             <a:endParaRPr lang="en-US"/>
           </a:p>
@@ -1873,10 +1875,9 @@
           <a:lstStyle/>
           <a:p>
             <a:r>
-              <a:rPr lang="en-US" smtClean="0"/>
+              <a:rPr lang="en-US"/>
               <a:t>Click to edit Master title style</a:t>
             </a:r>
-            <a:endParaRPr lang="en-US"/>
           </a:p>
         </p:txBody>
       </p:sp>
@@ -1897,7 +1898,7 @@
           <a:p>
             <a:fld id="{5BCAD085-E8A6-8845-BD4E-CB4CCA059FC4}" type="datetimeFigureOut">
               <a:rPr lang="en-US" smtClean="0"/>
-              <a:t>1/27/13</a:t>
+              <a:t>5/30/2026</a:t>
             </a:fld>
             <a:endParaRPr lang="en-US"/>
           </a:p>
@@ -1992,7 +1993,7 @@
           <a:p>
             <a:fld id="{5BCAD085-E8A6-8845-BD4E-CB4CCA059FC4}" type="datetimeFigureOut">
               <a:rPr lang="en-US" smtClean="0"/>
-              <a:t>1/27/13</a:t>
+              <a:t>5/30/2026</a:t>
             </a:fld>
             <a:endParaRPr lang="en-US"/>
           </a:p>
@@ -2095,10 +2096,9 @@
           </a:lstStyle>
           <a:p>
             <a:r>
-              <a:rPr lang="en-US" smtClean="0"/>
+              <a:rPr lang="en-US"/>
               <a:t>Click to edit Master title style</a:t>
             </a:r>
-            <a:endParaRPr lang="en-US"/>
           </a:p>
         </p:txBody>
       </p:sp>
@@ -2152,38 +2152,37 @@
           <a:p>
             <a:pPr lvl="0"/>
             <a:r>
-              <a:rPr lang="en-US" smtClean="0"/>
+              <a:rPr lang="en-US"/>
               <a:t>Click to edit Master text styles</a:t>
             </a:r>
           </a:p>
           <a:p>
             <a:pPr lvl="1"/>
             <a:r>
-              <a:rPr lang="en-US" smtClean="0"/>
+              <a:rPr lang="en-US"/>
               <a:t>Second level</a:t>
             </a:r>
           </a:p>
           <a:p>
             <a:pPr lvl="2"/>
             <a:r>
-              <a:rPr lang="en-US" smtClean="0"/>
+              <a:rPr lang="en-US"/>
               <a:t>Third level</a:t>
             </a:r>
           </a:p>
           <a:p>
             <a:pPr lvl="3"/>
             <a:r>
-              <a:rPr lang="en-US" smtClean="0"/>
+              <a:rPr lang="en-US"/>
               <a:t>Fourth level</a:t>
             </a:r>
           </a:p>
           <a:p>
             <a:pPr lvl="4"/>
             <a:r>
-              <a:rPr lang="en-US" smtClean="0"/>
+              <a:rPr lang="en-US"/>
               <a:t>Fifth level</a:t>
             </a:r>
-            <a:endParaRPr lang="en-US"/>
           </a:p>
         </p:txBody>
       </p:sp>
@@ -2246,7 +2245,7 @@
           <a:p>
             <a:pPr lvl="0"/>
             <a:r>
-              <a:rPr lang="en-US" smtClean="0"/>
+              <a:rPr lang="en-US"/>
               <a:t>Click to edit Master text styles</a:t>
             </a:r>
           </a:p>
@@ -2269,7 +2268,7 @@
           <a:p>
             <a:fld id="{5BCAD085-E8A6-8845-BD4E-CB4CCA059FC4}" type="datetimeFigureOut">
               <a:rPr lang="en-US" smtClean="0"/>
-              <a:t>1/27/13</a:t>
+              <a:t>5/30/2026</a:t>
             </a:fld>
             <a:endParaRPr lang="en-US"/>
           </a:p>
@@ -2372,10 +2371,9 @@
           </a:lstStyle>
           <a:p>
             <a:r>
-              <a:rPr lang="en-US" smtClean="0"/>
+              <a:rPr lang="en-US"/>
               <a:t>Click to edit Master title style</a:t>
             </a:r>
-            <a:endParaRPr lang="en-US"/>
           </a:p>
         </p:txBody>
       </p:sp>
@@ -2499,7 +2497,7 @@
           <a:p>
             <a:pPr lvl="0"/>
             <a:r>
-              <a:rPr lang="en-US" smtClean="0"/>
+              <a:rPr lang="en-US"/>
               <a:t>Click to edit Master text styles</a:t>
             </a:r>
           </a:p>
@@ -2522,7 +2520,7 @@
           <a:p>
             <a:fld id="{5BCAD085-E8A6-8845-BD4E-CB4CCA059FC4}" type="datetimeFigureOut">
               <a:rPr lang="en-US" smtClean="0"/>
-              <a:t>1/27/13</a:t>
+              <a:t>5/30/2026</a:t>
             </a:fld>
             <a:endParaRPr lang="en-US"/>
           </a:p>
@@ -2631,10 +2629,9 @@
           <a:lstStyle/>
           <a:p>
             <a:r>
-              <a:rPr lang="en-US" smtClean="0"/>
+              <a:rPr lang="en-US"/>
               <a:t>Click to edit Master title style</a:t>
             </a:r>
-            <a:endParaRPr lang="en-US"/>
           </a:p>
         </p:txBody>
       </p:sp>
@@ -2665,38 +2662,37 @@
           <a:p>
             <a:pPr lvl="0"/>
             <a:r>
-              <a:rPr lang="en-US" smtClean="0"/>
+              <a:rPr lang="en-US"/>
               <a:t>Click to edit Master text styles</a:t>
             </a:r>
           </a:p>
           <a:p>
             <a:pPr lvl="1"/>
             <a:r>
-              <a:rPr lang="en-US" smtClean="0"/>
+              <a:rPr lang="en-US"/>
               <a:t>Second level</a:t>
             </a:r>
           </a:p>
           <a:p>
             <a:pPr lvl="2"/>
             <a:r>
-              <a:rPr lang="en-US" smtClean="0"/>
+              <a:rPr lang="en-US"/>
               <a:t>Third level</a:t>
             </a:r>
           </a:p>
           <a:p>
             <a:pPr lvl="3"/>
             <a:r>
-              <a:rPr lang="en-US" smtClean="0"/>
+              <a:rPr lang="en-US"/>
               <a:t>Fourth level</a:t>
             </a:r>
           </a:p>
           <a:p>
             <a:pPr lvl="4"/>
             <a:r>
-              <a:rPr lang="en-US" smtClean="0"/>
+              <a:rPr lang="en-US"/>
               <a:t>Fifth level</a:t>
             </a:r>
-            <a:endParaRPr lang="en-US"/>
           </a:p>
         </p:txBody>
       </p:sp>
@@ -2735,7 +2731,7 @@
           <a:p>
             <a:fld id="{5BCAD085-E8A6-8845-BD4E-CB4CCA059FC4}" type="datetimeFigureOut">
               <a:rPr lang="en-US" smtClean="0"/>
-              <a:t>1/27/13</a:t>
+              <a:t>5/30/2026</a:t>
             </a:fld>
             <a:endParaRPr lang="en-US"/>
           </a:p>
@@ -3094,7 +3090,7 @@
 </file>
 
 <file path=ppt/slides/slide1.xml><?xml version="1.0" encoding="utf-8"?>
-<p:sld xmlns:a="http://schemas.openxmlformats.org/drawingml/2006/main" xmlns:p="http://schemas.openxmlformats.org/presentationml/2006/main" xmlns:r="http://schemas.openxmlformats.org/officeDocument/2006/relationships">
+<p:sld xmlns:a="http://schemas.openxmlformats.org/drawingml/2006/main" xmlns:r="http://schemas.openxmlformats.org/officeDocument/2006/relationships" xmlns:p="http://schemas.openxmlformats.org/presentationml/2006/main">
   <p:cSld>
     <p:bg>
       <p:bgPr>
@@ -3110,7 +3106,14 @@
         <p:cNvGrpSpPr/>
         <p:nvPr/>
       </p:nvGrpSpPr>
-      <p:grpSpPr/>
+      <p:grpSpPr>
+        <a:xfrm>
+          <a:off x="0" y="0"/>
+          <a:ext cx="0" cy="0"/>
+          <a:chOff x="0" y="0"/>
+          <a:chExt cx="0" cy="0"/>
+        </a:xfrm>
+      </p:grpSpPr>
       <p:sp>
         <p:nvSpPr>
           <p:cNvPr id="2" name="Rectangle 1"/>
@@ -3152,6 +3155,7 @@
           <a:lstStyle/>
           <a:p>
             <a:pPr algn="ctr"/>
+            <a:endParaRPr/>
           </a:p>
         </p:txBody>
       </p:sp>
@@ -3196,6 +3200,7 @@
           <a:lstStyle/>
           <a:p>
             <a:pPr algn="ctr"/>
+            <a:endParaRPr/>
           </a:p>
         </p:txBody>
       </p:sp>
@@ -3240,6 +3245,7 @@
           <a:lstStyle/>
           <a:p>
             <a:pPr algn="ctr"/>
+            <a:endParaRPr/>
           </a:p>
         </p:txBody>
       </p:sp>
@@ -3284,6 +3290,7 @@
           <a:lstStyle/>
           <a:p>
             <a:pPr algn="ctr"/>
+            <a:endParaRPr/>
           </a:p>
         </p:txBody>
       </p:sp>
@@ -3328,6 +3335,7 @@
           <a:lstStyle/>
           <a:p>
             <a:pPr algn="ctr"/>
+            <a:endParaRPr/>
           </a:p>
         </p:txBody>
       </p:sp>
@@ -3348,7 +3356,7 @@
           <a:noFill/>
         </p:spPr>
         <p:txBody>
-          <a:bodyPr wrap="square" anchor="t" lIns="0" rIns="0" tIns="0" bIns="0">
+          <a:bodyPr wrap="square" lIns="0" tIns="0" rIns="0" bIns="0" anchor="t">
             <a:spAutoFit/>
           </a:bodyPr>
           <a:lstStyle/>
@@ -3365,7 +3373,7 @@
               </a:spcAft>
             </a:pPr>
             <a:r>
-              <a:rPr sz="1400" b="1">
+              <a:rPr sz="1400" b="1" dirty="0">
                 <a:solidFill>
                   <a:srgbClr val="00E676"/>
                 </a:solidFill>
@@ -3393,7 +3401,7 @@
           <a:noFill/>
         </p:spPr>
         <p:txBody>
-          <a:bodyPr wrap="square" anchor="t" lIns="0" rIns="0" tIns="0" bIns="0">
+          <a:bodyPr wrap="square" lIns="0" tIns="0" rIns="0" bIns="0" anchor="t">
             <a:spAutoFit/>
           </a:bodyPr>
           <a:lstStyle/>
@@ -3410,7 +3418,7 @@
               </a:spcAft>
             </a:pPr>
             <a:r>
-              <a:rPr sz="7600" b="1">
+              <a:rPr sz="7600" b="1" dirty="0">
                 <a:solidFill>
                   <a:srgbClr val="EAF3EF"/>
                 </a:solidFill>
@@ -3462,6 +3470,7 @@
           <a:lstStyle/>
           <a:p>
             <a:pPr algn="ctr"/>
+            <a:endParaRPr/>
           </a:p>
         </p:txBody>
       </p:sp>
@@ -3482,7 +3491,7 @@
           <a:noFill/>
         </p:spPr>
         <p:txBody>
-          <a:bodyPr wrap="square" anchor="t" lIns="0" rIns="0" tIns="0" bIns="0">
+          <a:bodyPr wrap="square" lIns="0" tIns="0" rIns="0" bIns="0" anchor="t">
             <a:spAutoFit/>
           </a:bodyPr>
           <a:lstStyle/>
@@ -3499,7 +3508,7 @@
               </a:spcAft>
             </a:pPr>
             <a:r>
-              <a:rPr sz="2200" b="0">
+              <a:rPr sz="2200" b="0" dirty="0">
                 <a:solidFill>
                   <a:srgbClr val="8DA39B"/>
                 </a:solidFill>
@@ -3521,7 +3530,7 @@
               </a:spcAft>
             </a:pPr>
             <a:r>
-              <a:rPr sz="2200" b="0">
+              <a:rPr sz="2200" b="0" dirty="0">
                 <a:solidFill>
                   <a:srgbClr val="8DA39B"/>
                 </a:solidFill>
@@ -3569,7 +3578,7 @@
           </a:fontRef>
         </p:style>
         <p:txBody>
-          <a:bodyPr rtlCol="0" anchor="ctr" tIns="0" bIns="0"/>
+          <a:bodyPr tIns="0" bIns="0" rtlCol="0" anchor="ctr"/>
           <a:lstStyle/>
           <a:p>
             <a:pPr algn="ctr"/>
@@ -3622,7 +3631,7 @@
           </a:fontRef>
         </p:style>
         <p:txBody>
-          <a:bodyPr rtlCol="0" anchor="ctr" tIns="0" bIns="0"/>
+          <a:bodyPr tIns="0" bIns="0" rtlCol="0" anchor="ctr"/>
           <a:lstStyle/>
           <a:p>
             <a:pPr algn="ctr"/>
@@ -3675,7 +3684,7 @@
           </a:fontRef>
         </p:style>
         <p:txBody>
-          <a:bodyPr rtlCol="0" anchor="ctr" tIns="0" bIns="0"/>
+          <a:bodyPr tIns="0" bIns="0" rtlCol="0" anchor="ctr"/>
           <a:lstStyle/>
           <a:p>
             <a:pPr algn="ctr"/>
@@ -3728,7 +3737,7 @@
           </a:fontRef>
         </p:style>
         <p:txBody>
-          <a:bodyPr rtlCol="0" anchor="ctr" tIns="0" bIns="0"/>
+          <a:bodyPr tIns="0" bIns="0" rtlCol="0" anchor="ctr"/>
           <a:lstStyle/>
           <a:p>
             <a:pPr algn="ctr"/>
@@ -3785,6 +3794,7 @@
           <a:lstStyle/>
           <a:p>
             <a:pPr algn="ctr"/>
+            <a:endParaRPr/>
           </a:p>
         </p:txBody>
       </p:sp>
@@ -3805,7 +3815,7 @@
           <a:noFill/>
         </p:spPr>
         <p:txBody>
-          <a:bodyPr wrap="square" anchor="t" lIns="0" rIns="0" tIns="0" bIns="0">
+          <a:bodyPr wrap="square" lIns="0" tIns="0" rIns="0" bIns="0" anchor="t">
             <a:spAutoFit/>
           </a:bodyPr>
           <a:lstStyle/>
@@ -3837,7 +3847,7 @@
                 </a:solidFill>
                 <a:latin typeface="Segoe UI"/>
               </a:rPr>
-              <a:t>   ·   Datalake 3.0 integration module   ·   v1.0.0</a:t>
+              <a:t>   ·   Datalake 3.0 integration module   ·   v1.1.0</a:t>
             </a:r>
           </a:p>
         </p:txBody>
@@ -3851,7 +3861,7 @@
 </file>
 
 <file path=ppt/slides/slide10.xml><?xml version="1.0" encoding="utf-8"?>
-<p:sld xmlns:a="http://schemas.openxmlformats.org/drawingml/2006/main" xmlns:p="http://schemas.openxmlformats.org/presentationml/2006/main" xmlns:r="http://schemas.openxmlformats.org/officeDocument/2006/relationships">
+<p:sld xmlns:a="http://schemas.openxmlformats.org/drawingml/2006/main" xmlns:r="http://schemas.openxmlformats.org/officeDocument/2006/relationships" xmlns:p="http://schemas.openxmlformats.org/presentationml/2006/main">
   <p:cSld>
     <p:bg>
       <p:bgPr>
@@ -3867,7 +3877,14 @@
         <p:cNvGrpSpPr/>
         <p:nvPr/>
       </p:nvGrpSpPr>
-      <p:grpSpPr/>
+      <p:grpSpPr>
+        <a:xfrm>
+          <a:off x="0" y="0"/>
+          <a:ext cx="0" cy="0"/>
+          <a:chOff x="0" y="0"/>
+          <a:chExt cx="0" cy="0"/>
+        </a:xfrm>
+      </p:grpSpPr>
       <p:sp>
         <p:nvSpPr>
           <p:cNvPr id="2" name="Rectangle 1"/>
@@ -3909,6 +3926,7 @@
           <a:lstStyle/>
           <a:p>
             <a:pPr algn="ctr"/>
+            <a:endParaRPr/>
           </a:p>
         </p:txBody>
       </p:sp>
@@ -3953,6 +3971,7 @@
           <a:lstStyle/>
           <a:p>
             <a:pPr algn="ctr"/>
+            <a:endParaRPr/>
           </a:p>
         </p:txBody>
       </p:sp>
@@ -3997,6 +4016,7 @@
           <a:lstStyle/>
           <a:p>
             <a:pPr algn="ctr"/>
+            <a:endParaRPr/>
           </a:p>
         </p:txBody>
       </p:sp>
@@ -4017,7 +4037,7 @@
           <a:noFill/>
         </p:spPr>
         <p:txBody>
-          <a:bodyPr wrap="square" anchor="t" lIns="0" rIns="0" tIns="0" bIns="0">
+          <a:bodyPr wrap="square" lIns="0" tIns="0" rIns="0" bIns="0" anchor="t">
             <a:spAutoFit/>
           </a:bodyPr>
           <a:lstStyle/>
@@ -4071,7 +4091,7 @@
           <a:noFill/>
         </p:spPr>
         <p:txBody>
-          <a:bodyPr wrap="square" anchor="t" lIns="0" rIns="0" tIns="0" bIns="0">
+          <a:bodyPr wrap="square" lIns="0" tIns="0" rIns="0" bIns="0" anchor="t">
             <a:spAutoFit/>
           </a:bodyPr>
           <a:lstStyle/>
@@ -4140,6 +4160,7 @@
           <a:lstStyle/>
           <a:p>
             <a:pPr algn="ctr"/>
+            <a:endParaRPr/>
           </a:p>
         </p:txBody>
       </p:sp>
@@ -4160,7 +4181,7 @@
           <a:noFill/>
         </p:spPr>
         <p:txBody>
-          <a:bodyPr wrap="square" anchor="t" lIns="0" rIns="0" tIns="0" bIns="0">
+          <a:bodyPr wrap="square" lIns="0" tIns="0" rIns="0" bIns="0" anchor="t">
             <a:spAutoFit/>
           </a:bodyPr>
           <a:lstStyle/>
@@ -4205,7 +4226,7 @@
           <a:noFill/>
         </p:spPr>
         <p:txBody>
-          <a:bodyPr wrap="square" anchor="t" lIns="0" rIns="0" tIns="0" bIns="0">
+          <a:bodyPr wrap="square" lIns="0" tIns="0" rIns="0" bIns="0" anchor="t">
             <a:spAutoFit/>
           </a:bodyPr>
           <a:lstStyle/>
@@ -4274,6 +4295,7 @@
           <a:lstStyle/>
           <a:p>
             <a:pPr algn="ctr"/>
+            <a:endParaRPr/>
           </a:p>
         </p:txBody>
       </p:sp>
@@ -4318,6 +4340,7 @@
           <a:lstStyle/>
           <a:p>
             <a:pPr algn="ctr"/>
+            <a:endParaRPr/>
           </a:p>
         </p:txBody>
       </p:sp>
@@ -4364,6 +4387,7 @@
           <a:lstStyle/>
           <a:p>
             <a:pPr algn="ctr"/>
+            <a:endParaRPr/>
           </a:p>
         </p:txBody>
       </p:sp>
@@ -4384,7 +4408,7 @@
           <a:noFill/>
         </p:spPr>
         <p:txBody>
-          <a:bodyPr wrap="square" anchor="t" lIns="0" rIns="0" tIns="0" bIns="0">
+          <a:bodyPr wrap="square" lIns="0" tIns="0" rIns="0" bIns="0" anchor="t">
             <a:spAutoFit/>
           </a:bodyPr>
           <a:lstStyle/>
@@ -4499,6 +4523,7 @@
           <a:lstStyle/>
           <a:p>
             <a:pPr algn="ctr"/>
+            <a:endParaRPr/>
           </a:p>
         </p:txBody>
       </p:sp>
@@ -4519,7 +4544,7 @@
           <a:noFill/>
         </p:spPr>
         <p:txBody>
-          <a:bodyPr wrap="square" anchor="t" lIns="0" rIns="0" tIns="0" bIns="0">
+          <a:bodyPr wrap="square" lIns="0" tIns="0" rIns="0" bIns="0" anchor="t">
             <a:spAutoFit/>
           </a:bodyPr>
           <a:lstStyle/>
@@ -4634,6 +4659,7 @@
           <a:lstStyle/>
           <a:p>
             <a:pPr algn="ctr"/>
+            <a:endParaRPr/>
           </a:p>
         </p:txBody>
       </p:sp>
@@ -4654,7 +4680,7 @@
           <a:noFill/>
         </p:spPr>
         <p:txBody>
-          <a:bodyPr wrap="square" anchor="t" lIns="0" rIns="0" tIns="0" bIns="0">
+          <a:bodyPr wrap="square" lIns="0" tIns="0" rIns="0" bIns="0" anchor="t">
             <a:spAutoFit/>
           </a:bodyPr>
           <a:lstStyle/>
@@ -4769,6 +4795,7 @@
           <a:lstStyle/>
           <a:p>
             <a:pPr algn="ctr"/>
+            <a:endParaRPr/>
           </a:p>
         </p:txBody>
       </p:sp>
@@ -4789,7 +4816,7 @@
           <a:noFill/>
         </p:spPr>
         <p:txBody>
-          <a:bodyPr wrap="square" anchor="t" lIns="0" rIns="0" tIns="0" bIns="0">
+          <a:bodyPr wrap="square" lIns="0" tIns="0" rIns="0" bIns="0" anchor="t">
             <a:spAutoFit/>
           </a:bodyPr>
           <a:lstStyle/>
@@ -4880,10 +4907,34 @@
                 <a:tableStyleId>{5C22544A-7EE6-4342-B048-85BDC9FD1C3A}</a:tableStyleId>
               </a:tblPr>
               <a:tblGrid>
-                <a:gridCol w="4206240"/>
-                <a:gridCol w="1828800"/>
-                <a:gridCol w="2331720"/>
-                <a:gridCol w="2148840"/>
+                <a:gridCol w="4206240">
+                  <a:extLst>
+                    <a:ext uri="{9D8B030D-6E8A-4147-A177-3AD203B41FA5}">
+                      <a16:colId xmlns:a16="http://schemas.microsoft.com/office/drawing/2014/main" val="20000"/>
+                    </a:ext>
+                  </a:extLst>
+                </a:gridCol>
+                <a:gridCol w="1828800">
+                  <a:extLst>
+                    <a:ext uri="{9D8B030D-6E8A-4147-A177-3AD203B41FA5}">
+                      <a16:colId xmlns:a16="http://schemas.microsoft.com/office/drawing/2014/main" val="20001"/>
+                    </a:ext>
+                  </a:extLst>
+                </a:gridCol>
+                <a:gridCol w="2331720">
+                  <a:extLst>
+                    <a:ext uri="{9D8B030D-6E8A-4147-A177-3AD203B41FA5}">
+                      <a16:colId xmlns:a16="http://schemas.microsoft.com/office/drawing/2014/main" val="20002"/>
+                    </a:ext>
+                  </a:extLst>
+                </a:gridCol>
+                <a:gridCol w="2148840">
+                  <a:extLst>
+                    <a:ext uri="{9D8B030D-6E8A-4147-A177-3AD203B41FA5}">
+                      <a16:colId xmlns:a16="http://schemas.microsoft.com/office/drawing/2014/main" val="20003"/>
+                    </a:ext>
+                  </a:extLst>
+                </a:gridCol>
               </a:tblGrid>
               <a:tr h="420624">
                 <a:tc>
@@ -4978,6 +5029,11 @@
                     </a:solidFill>
                   </a:tcPr>
                 </a:tc>
+                <a:extLst>
+                  <a:ext uri="{0D108BD9-81ED-4DB2-BD59-A6C34878D82A}">
+                    <a16:rowId xmlns:a16="http://schemas.microsoft.com/office/drawing/2014/main" val="10000"/>
+                  </a:ext>
+                </a:extLst>
               </a:tr>
               <a:tr h="402336">
                 <a:tc>
@@ -5072,6 +5128,11 @@
                     </a:solidFill>
                   </a:tcPr>
                 </a:tc>
+                <a:extLst>
+                  <a:ext uri="{0D108BD9-81ED-4DB2-BD59-A6C34878D82A}">
+                    <a16:rowId xmlns:a16="http://schemas.microsoft.com/office/drawing/2014/main" val="10001"/>
+                  </a:ext>
+                </a:extLst>
               </a:tr>
               <a:tr h="402336">
                 <a:tc>
@@ -5166,6 +5227,11 @@
                     </a:solidFill>
                   </a:tcPr>
                 </a:tc>
+                <a:extLst>
+                  <a:ext uri="{0D108BD9-81ED-4DB2-BD59-A6C34878D82A}">
+                    <a16:rowId xmlns:a16="http://schemas.microsoft.com/office/drawing/2014/main" val="10002"/>
+                  </a:ext>
+                </a:extLst>
               </a:tr>
               <a:tr h="402336">
                 <a:tc>
@@ -5260,6 +5326,11 @@
                     </a:solidFill>
                   </a:tcPr>
                 </a:tc>
+                <a:extLst>
+                  <a:ext uri="{0D108BD9-81ED-4DB2-BD59-A6C34878D82A}">
+                    <a16:rowId xmlns:a16="http://schemas.microsoft.com/office/drawing/2014/main" val="10003"/>
+                  </a:ext>
+                </a:extLst>
               </a:tr>
             </a:tbl>
           </a:graphicData>
@@ -5282,7 +5353,7 @@
           <a:noFill/>
         </p:spPr>
         <p:txBody>
-          <a:bodyPr wrap="square" anchor="t" lIns="0" rIns="0" tIns="0" bIns="0">
+          <a:bodyPr wrap="square" lIns="0" tIns="0" rIns="0" bIns="0" anchor="t">
             <a:spAutoFit/>
           </a:bodyPr>
           <a:lstStyle/>
@@ -5341,7 +5412,7 @@
 </file>
 
 <file path=ppt/slides/slide11.xml><?xml version="1.0" encoding="utf-8"?>
-<p:sld xmlns:a="http://schemas.openxmlformats.org/drawingml/2006/main" xmlns:p="http://schemas.openxmlformats.org/presentationml/2006/main" xmlns:r="http://schemas.openxmlformats.org/officeDocument/2006/relationships">
+<p:sld xmlns:a="http://schemas.openxmlformats.org/drawingml/2006/main" xmlns:r="http://schemas.openxmlformats.org/officeDocument/2006/relationships" xmlns:p="http://schemas.openxmlformats.org/presentationml/2006/main">
   <p:cSld>
     <p:bg>
       <p:bgPr>
@@ -5357,7 +5428,14 @@
         <p:cNvGrpSpPr/>
         <p:nvPr/>
       </p:nvGrpSpPr>
-      <p:grpSpPr/>
+      <p:grpSpPr>
+        <a:xfrm>
+          <a:off x="0" y="0"/>
+          <a:ext cx="0" cy="0"/>
+          <a:chOff x="0" y="0"/>
+          <a:chExt cx="0" cy="0"/>
+        </a:xfrm>
+      </p:grpSpPr>
       <p:sp>
         <p:nvSpPr>
           <p:cNvPr id="2" name="Rectangle 1"/>
@@ -5399,6 +5477,7 @@
           <a:lstStyle/>
           <a:p>
             <a:pPr algn="ctr"/>
+            <a:endParaRPr/>
           </a:p>
         </p:txBody>
       </p:sp>
@@ -5443,6 +5522,7 @@
           <a:lstStyle/>
           <a:p>
             <a:pPr algn="ctr"/>
+            <a:endParaRPr/>
           </a:p>
         </p:txBody>
       </p:sp>
@@ -5487,6 +5567,7 @@
           <a:lstStyle/>
           <a:p>
             <a:pPr algn="ctr"/>
+            <a:endParaRPr/>
           </a:p>
         </p:txBody>
       </p:sp>
@@ -5507,7 +5588,7 @@
           <a:noFill/>
         </p:spPr>
         <p:txBody>
-          <a:bodyPr wrap="square" anchor="t" lIns="0" rIns="0" tIns="0" bIns="0">
+          <a:bodyPr wrap="square" lIns="0" tIns="0" rIns="0" bIns="0" anchor="t">
             <a:spAutoFit/>
           </a:bodyPr>
           <a:lstStyle/>
@@ -5561,7 +5642,7 @@
           <a:noFill/>
         </p:spPr>
         <p:txBody>
-          <a:bodyPr wrap="square" anchor="t" lIns="0" rIns="0" tIns="0" bIns="0">
+          <a:bodyPr wrap="square" lIns="0" tIns="0" rIns="0" bIns="0" anchor="t">
             <a:spAutoFit/>
           </a:bodyPr>
           <a:lstStyle/>
@@ -5630,6 +5711,7 @@
           <a:lstStyle/>
           <a:p>
             <a:pPr algn="ctr"/>
+            <a:endParaRPr/>
           </a:p>
         </p:txBody>
       </p:sp>
@@ -5650,7 +5732,7 @@
           <a:noFill/>
         </p:spPr>
         <p:txBody>
-          <a:bodyPr wrap="square" anchor="t" lIns="0" rIns="0" tIns="0" bIns="0">
+          <a:bodyPr wrap="square" lIns="0" tIns="0" rIns="0" bIns="0" anchor="t">
             <a:spAutoFit/>
           </a:bodyPr>
           <a:lstStyle/>
@@ -5695,7 +5777,7 @@
           <a:noFill/>
         </p:spPr>
         <p:txBody>
-          <a:bodyPr wrap="square" anchor="t" lIns="0" rIns="0" tIns="0" bIns="0">
+          <a:bodyPr wrap="square" lIns="0" tIns="0" rIns="0" bIns="0" anchor="t">
             <a:spAutoFit/>
           </a:bodyPr>
           <a:lstStyle/>
@@ -5764,6 +5846,7 @@
           <a:lstStyle/>
           <a:p>
             <a:pPr algn="ctr"/>
+            <a:endParaRPr/>
           </a:p>
         </p:txBody>
       </p:sp>
@@ -5808,6 +5891,7 @@
           <a:lstStyle/>
           <a:p>
             <a:pPr algn="ctr"/>
+            <a:endParaRPr/>
           </a:p>
         </p:txBody>
       </p:sp>
@@ -5854,6 +5938,7 @@
           <a:lstStyle/>
           <a:p>
             <a:pPr algn="ctr"/>
+            <a:endParaRPr/>
           </a:p>
         </p:txBody>
       </p:sp>
@@ -5898,6 +5983,7 @@
           <a:lstStyle/>
           <a:p>
             <a:pPr algn="ctr"/>
+            <a:endParaRPr/>
           </a:p>
         </p:txBody>
       </p:sp>
@@ -5918,7 +6004,7 @@
           <a:noFill/>
         </p:spPr>
         <p:txBody>
-          <a:bodyPr wrap="square" anchor="ctr" lIns="0" rIns="0" tIns="0" bIns="0">
+          <a:bodyPr wrap="square" lIns="0" tIns="0" rIns="0" bIns="0" anchor="ctr">
             <a:spAutoFit/>
           </a:bodyPr>
           <a:lstStyle/>
@@ -6009,6 +6095,7 @@
           <a:lstStyle/>
           <a:p>
             <a:pPr algn="ctr"/>
+            <a:endParaRPr/>
           </a:p>
         </p:txBody>
       </p:sp>
@@ -6055,6 +6142,7 @@
           <a:lstStyle/>
           <a:p>
             <a:pPr algn="ctr"/>
+            <a:endParaRPr/>
           </a:p>
         </p:txBody>
       </p:sp>
@@ -6099,6 +6187,7 @@
           <a:lstStyle/>
           <a:p>
             <a:pPr algn="ctr"/>
+            <a:endParaRPr/>
           </a:p>
         </p:txBody>
       </p:sp>
@@ -6119,7 +6208,7 @@
           <a:noFill/>
         </p:spPr>
         <p:txBody>
-          <a:bodyPr wrap="square" anchor="ctr" lIns="0" rIns="0" tIns="0" bIns="0">
+          <a:bodyPr wrap="square" lIns="0" tIns="0" rIns="0" bIns="0" anchor="ctr">
             <a:spAutoFit/>
           </a:bodyPr>
           <a:lstStyle/>
@@ -6210,6 +6299,7 @@
           <a:lstStyle/>
           <a:p>
             <a:pPr algn="ctr"/>
+            <a:endParaRPr/>
           </a:p>
         </p:txBody>
       </p:sp>
@@ -6256,6 +6346,7 @@
           <a:lstStyle/>
           <a:p>
             <a:pPr algn="ctr"/>
+            <a:endParaRPr/>
           </a:p>
         </p:txBody>
       </p:sp>
@@ -6300,6 +6391,7 @@
           <a:lstStyle/>
           <a:p>
             <a:pPr algn="ctr"/>
+            <a:endParaRPr/>
           </a:p>
         </p:txBody>
       </p:sp>
@@ -6320,7 +6412,7 @@
           <a:noFill/>
         </p:spPr>
         <p:txBody>
-          <a:bodyPr wrap="square" anchor="ctr" lIns="0" rIns="0" tIns="0" bIns="0">
+          <a:bodyPr wrap="square" lIns="0" tIns="0" rIns="0" bIns="0" anchor="ctr">
             <a:spAutoFit/>
           </a:bodyPr>
           <a:lstStyle/>
@@ -6411,6 +6503,7 @@
           <a:lstStyle/>
           <a:p>
             <a:pPr algn="ctr"/>
+            <a:endParaRPr/>
           </a:p>
         </p:txBody>
       </p:sp>
@@ -6457,6 +6550,7 @@
           <a:lstStyle/>
           <a:p>
             <a:pPr algn="ctr"/>
+            <a:endParaRPr/>
           </a:p>
         </p:txBody>
       </p:sp>
@@ -6501,6 +6595,7 @@
           <a:lstStyle/>
           <a:p>
             <a:pPr algn="ctr"/>
+            <a:endParaRPr/>
           </a:p>
         </p:txBody>
       </p:sp>
@@ -6521,7 +6616,7 @@
           <a:noFill/>
         </p:spPr>
         <p:txBody>
-          <a:bodyPr wrap="square" anchor="ctr" lIns="0" rIns="0" tIns="0" bIns="0">
+          <a:bodyPr wrap="square" lIns="0" tIns="0" rIns="0" bIns="0" anchor="ctr">
             <a:spAutoFit/>
           </a:bodyPr>
           <a:lstStyle/>
@@ -6612,6 +6707,7 @@
           <a:lstStyle/>
           <a:p>
             <a:pPr algn="ctr"/>
+            <a:endParaRPr/>
           </a:p>
         </p:txBody>
       </p:sp>
@@ -6658,6 +6754,7 @@
           <a:lstStyle/>
           <a:p>
             <a:pPr algn="ctr"/>
+            <a:endParaRPr/>
           </a:p>
         </p:txBody>
       </p:sp>
@@ -6702,6 +6799,7 @@
           <a:lstStyle/>
           <a:p>
             <a:pPr algn="ctr"/>
+            <a:endParaRPr/>
           </a:p>
         </p:txBody>
       </p:sp>
@@ -6722,7 +6820,7 @@
           <a:noFill/>
         </p:spPr>
         <p:txBody>
-          <a:bodyPr wrap="square" anchor="ctr" lIns="0" rIns="0" tIns="0" bIns="0">
+          <a:bodyPr wrap="square" lIns="0" tIns="0" rIns="0" bIns="0" anchor="ctr">
             <a:spAutoFit/>
           </a:bodyPr>
           <a:lstStyle/>
@@ -6781,7 +6879,7 @@
 </file>
 
 <file path=ppt/slides/slide12.xml><?xml version="1.0" encoding="utf-8"?>
-<p:sld xmlns:a="http://schemas.openxmlformats.org/drawingml/2006/main" xmlns:p="http://schemas.openxmlformats.org/presentationml/2006/main" xmlns:r="http://schemas.openxmlformats.org/officeDocument/2006/relationships">
+<p:sld xmlns:a="http://schemas.openxmlformats.org/drawingml/2006/main" xmlns:r="http://schemas.openxmlformats.org/officeDocument/2006/relationships" xmlns:p="http://schemas.openxmlformats.org/presentationml/2006/main">
   <p:cSld>
     <p:bg>
       <p:bgPr>
@@ -6797,7 +6895,14 @@
         <p:cNvGrpSpPr/>
         <p:nvPr/>
       </p:nvGrpSpPr>
-      <p:grpSpPr/>
+      <p:grpSpPr>
+        <a:xfrm>
+          <a:off x="0" y="0"/>
+          <a:ext cx="0" cy="0"/>
+          <a:chOff x="0" y="0"/>
+          <a:chExt cx="0" cy="0"/>
+        </a:xfrm>
+      </p:grpSpPr>
       <p:sp>
         <p:nvSpPr>
           <p:cNvPr id="2" name="Rectangle 1"/>
@@ -6839,6 +6944,7 @@
           <a:lstStyle/>
           <a:p>
             <a:pPr algn="ctr"/>
+            <a:endParaRPr/>
           </a:p>
         </p:txBody>
       </p:sp>
@@ -6883,6 +6989,7 @@
           <a:lstStyle/>
           <a:p>
             <a:pPr algn="ctr"/>
+            <a:endParaRPr/>
           </a:p>
         </p:txBody>
       </p:sp>
@@ -6927,6 +7034,7 @@
           <a:lstStyle/>
           <a:p>
             <a:pPr algn="ctr"/>
+            <a:endParaRPr/>
           </a:p>
         </p:txBody>
       </p:sp>
@@ -6947,7 +7055,7 @@
           <a:noFill/>
         </p:spPr>
         <p:txBody>
-          <a:bodyPr wrap="square" anchor="t" lIns="0" rIns="0" tIns="0" bIns="0">
+          <a:bodyPr wrap="square" lIns="0" tIns="0" rIns="0" bIns="0" anchor="t">
             <a:spAutoFit/>
           </a:bodyPr>
           <a:lstStyle/>
@@ -7001,7 +7109,7 @@
           <a:noFill/>
         </p:spPr>
         <p:txBody>
-          <a:bodyPr wrap="square" anchor="t" lIns="0" rIns="0" tIns="0" bIns="0">
+          <a:bodyPr wrap="square" lIns="0" tIns="0" rIns="0" bIns="0" anchor="t">
             <a:spAutoFit/>
           </a:bodyPr>
           <a:lstStyle/>
@@ -7070,6 +7178,7 @@
           <a:lstStyle/>
           <a:p>
             <a:pPr algn="ctr"/>
+            <a:endParaRPr/>
           </a:p>
         </p:txBody>
       </p:sp>
@@ -7090,7 +7199,7 @@
           <a:noFill/>
         </p:spPr>
         <p:txBody>
-          <a:bodyPr wrap="square" anchor="t" lIns="0" rIns="0" tIns="0" bIns="0">
+          <a:bodyPr wrap="square" lIns="0" tIns="0" rIns="0" bIns="0" anchor="t">
             <a:spAutoFit/>
           </a:bodyPr>
           <a:lstStyle/>
@@ -7135,7 +7244,7 @@
           <a:noFill/>
         </p:spPr>
         <p:txBody>
-          <a:bodyPr wrap="square" anchor="t" lIns="0" rIns="0" tIns="0" bIns="0">
+          <a:bodyPr wrap="square" lIns="0" tIns="0" rIns="0" bIns="0" anchor="t">
             <a:spAutoFit/>
           </a:bodyPr>
           <a:lstStyle/>
@@ -7204,6 +7313,7 @@
           <a:lstStyle/>
           <a:p>
             <a:pPr algn="ctr"/>
+            <a:endParaRPr/>
           </a:p>
         </p:txBody>
       </p:sp>
@@ -7248,6 +7358,7 @@
           <a:lstStyle/>
           <a:p>
             <a:pPr algn="ctr"/>
+            <a:endParaRPr/>
           </a:p>
         </p:txBody>
       </p:sp>
@@ -7268,7 +7379,7 @@
           <a:noFill/>
         </p:spPr>
         <p:txBody>
-          <a:bodyPr wrap="square" anchor="t" lIns="0" rIns="0" tIns="0" bIns="0">
+          <a:bodyPr wrap="square" lIns="0" tIns="0" rIns="0" bIns="0" anchor="t">
             <a:spAutoFit/>
           </a:bodyPr>
           <a:lstStyle/>
@@ -7517,6 +7628,7 @@
           <a:lstStyle/>
           <a:p>
             <a:pPr algn="ctr"/>
+            <a:endParaRPr/>
           </a:p>
         </p:txBody>
       </p:sp>
@@ -7561,6 +7673,7 @@
           <a:lstStyle/>
           <a:p>
             <a:pPr algn="ctr"/>
+            <a:endParaRPr/>
           </a:p>
         </p:txBody>
       </p:sp>
@@ -7581,7 +7694,7 @@
           <a:noFill/>
         </p:spPr>
         <p:txBody>
-          <a:bodyPr wrap="square" anchor="ctr" lIns="0" rIns="0" tIns="0" bIns="0">
+          <a:bodyPr wrap="square" lIns="0" tIns="0" rIns="0" bIns="0" anchor="ctr">
             <a:spAutoFit/>
           </a:bodyPr>
           <a:lstStyle/>
@@ -7636,7 +7749,7 @@
 </file>
 
 <file path=ppt/slides/slide13.xml><?xml version="1.0" encoding="utf-8"?>
-<p:sld xmlns:a="http://schemas.openxmlformats.org/drawingml/2006/main" xmlns:p="http://schemas.openxmlformats.org/presentationml/2006/main" xmlns:r="http://schemas.openxmlformats.org/officeDocument/2006/relationships">
+<p:sld xmlns:a="http://schemas.openxmlformats.org/drawingml/2006/main" xmlns:r="http://schemas.openxmlformats.org/officeDocument/2006/relationships" xmlns:p="http://schemas.openxmlformats.org/presentationml/2006/main">
   <p:cSld>
     <p:bg>
       <p:bgPr>
@@ -7652,7 +7765,14 @@
         <p:cNvGrpSpPr/>
         <p:nvPr/>
       </p:nvGrpSpPr>
-      <p:grpSpPr/>
+      <p:grpSpPr>
+        <a:xfrm>
+          <a:off x="0" y="0"/>
+          <a:ext cx="0" cy="0"/>
+          <a:chOff x="0" y="0"/>
+          <a:chExt cx="0" cy="0"/>
+        </a:xfrm>
+      </p:grpSpPr>
       <p:sp>
         <p:nvSpPr>
           <p:cNvPr id="2" name="Rectangle 1"/>
@@ -7694,6 +7814,7 @@
           <a:lstStyle/>
           <a:p>
             <a:pPr algn="ctr"/>
+            <a:endParaRPr/>
           </a:p>
         </p:txBody>
       </p:sp>
@@ -7738,6 +7859,7 @@
           <a:lstStyle/>
           <a:p>
             <a:pPr algn="ctr"/>
+            <a:endParaRPr/>
           </a:p>
         </p:txBody>
       </p:sp>
@@ -7782,6 +7904,7 @@
           <a:lstStyle/>
           <a:p>
             <a:pPr algn="ctr"/>
+            <a:endParaRPr/>
           </a:p>
         </p:txBody>
       </p:sp>
@@ -7802,7 +7925,7 @@
           <a:noFill/>
         </p:spPr>
         <p:txBody>
-          <a:bodyPr wrap="square" anchor="t" lIns="0" rIns="0" tIns="0" bIns="0">
+          <a:bodyPr wrap="square" lIns="0" tIns="0" rIns="0" bIns="0" anchor="t">
             <a:spAutoFit/>
           </a:bodyPr>
           <a:lstStyle/>
@@ -7856,7 +7979,7 @@
           <a:noFill/>
         </p:spPr>
         <p:txBody>
-          <a:bodyPr wrap="square" anchor="t" lIns="0" rIns="0" tIns="0" bIns="0">
+          <a:bodyPr wrap="square" lIns="0" tIns="0" rIns="0" bIns="0" anchor="t">
             <a:spAutoFit/>
           </a:bodyPr>
           <a:lstStyle/>
@@ -7925,6 +8048,7 @@
           <a:lstStyle/>
           <a:p>
             <a:pPr algn="ctr"/>
+            <a:endParaRPr/>
           </a:p>
         </p:txBody>
       </p:sp>
@@ -7945,7 +8069,7 @@
           <a:noFill/>
         </p:spPr>
         <p:txBody>
-          <a:bodyPr wrap="square" anchor="t" lIns="0" rIns="0" tIns="0" bIns="0">
+          <a:bodyPr wrap="square" lIns="0" tIns="0" rIns="0" bIns="0" anchor="t">
             <a:spAutoFit/>
           </a:bodyPr>
           <a:lstStyle/>
@@ -7990,7 +8114,7 @@
           <a:noFill/>
         </p:spPr>
         <p:txBody>
-          <a:bodyPr wrap="square" anchor="t" lIns="0" rIns="0" tIns="0" bIns="0">
+          <a:bodyPr wrap="square" lIns="0" tIns="0" rIns="0" bIns="0" anchor="t">
             <a:spAutoFit/>
           </a:bodyPr>
           <a:lstStyle/>
@@ -8059,6 +8183,7 @@
           <a:lstStyle/>
           <a:p>
             <a:pPr algn="ctr"/>
+            <a:endParaRPr/>
           </a:p>
         </p:txBody>
       </p:sp>
@@ -8103,6 +8228,7 @@
           <a:lstStyle/>
           <a:p>
             <a:pPr algn="ctr"/>
+            <a:endParaRPr/>
           </a:p>
         </p:txBody>
       </p:sp>
@@ -8123,7 +8249,7 @@
           <a:noFill/>
         </p:spPr>
         <p:txBody>
-          <a:bodyPr wrap="square" anchor="t" lIns="0" rIns="0" tIns="0" bIns="0">
+          <a:bodyPr wrap="square" lIns="0" tIns="0" rIns="0" bIns="0" anchor="t">
             <a:spAutoFit/>
           </a:bodyPr>
           <a:lstStyle/>
@@ -8338,7 +8464,7 @@
 </file>
 
 <file path=ppt/slides/slide14.xml><?xml version="1.0" encoding="utf-8"?>
-<p:sld xmlns:a="http://schemas.openxmlformats.org/drawingml/2006/main" xmlns:p="http://schemas.openxmlformats.org/presentationml/2006/main" xmlns:r="http://schemas.openxmlformats.org/officeDocument/2006/relationships">
+<p:sld xmlns:a="http://schemas.openxmlformats.org/drawingml/2006/main" xmlns:r="http://schemas.openxmlformats.org/officeDocument/2006/relationships" xmlns:p="http://schemas.openxmlformats.org/presentationml/2006/main">
   <p:cSld>
     <p:bg>
       <p:bgPr>
@@ -8354,7 +8480,14 @@
         <p:cNvGrpSpPr/>
         <p:nvPr/>
       </p:nvGrpSpPr>
-      <p:grpSpPr/>
+      <p:grpSpPr>
+        <a:xfrm>
+          <a:off x="0" y="0"/>
+          <a:ext cx="0" cy="0"/>
+          <a:chOff x="0" y="0"/>
+          <a:chExt cx="0" cy="0"/>
+        </a:xfrm>
+      </p:grpSpPr>
       <p:sp>
         <p:nvSpPr>
           <p:cNvPr id="2" name="Rectangle 1"/>
@@ -8396,6 +8529,7 @@
           <a:lstStyle/>
           <a:p>
             <a:pPr algn="ctr"/>
+            <a:endParaRPr/>
           </a:p>
         </p:txBody>
       </p:sp>
@@ -8440,6 +8574,7 @@
           <a:lstStyle/>
           <a:p>
             <a:pPr algn="ctr"/>
+            <a:endParaRPr/>
           </a:p>
         </p:txBody>
       </p:sp>
@@ -8484,6 +8619,7 @@
           <a:lstStyle/>
           <a:p>
             <a:pPr algn="ctr"/>
+            <a:endParaRPr/>
           </a:p>
         </p:txBody>
       </p:sp>
@@ -8504,7 +8640,7 @@
           <a:noFill/>
         </p:spPr>
         <p:txBody>
-          <a:bodyPr wrap="square" anchor="t" lIns="0" rIns="0" tIns="0" bIns="0">
+          <a:bodyPr wrap="square" lIns="0" tIns="0" rIns="0" bIns="0" anchor="t">
             <a:spAutoFit/>
           </a:bodyPr>
           <a:lstStyle/>
@@ -8558,7 +8694,7 @@
           <a:noFill/>
         </p:spPr>
         <p:txBody>
-          <a:bodyPr wrap="square" anchor="t" lIns="0" rIns="0" tIns="0" bIns="0">
+          <a:bodyPr wrap="square" lIns="0" tIns="0" rIns="0" bIns="0" anchor="t">
             <a:spAutoFit/>
           </a:bodyPr>
           <a:lstStyle/>
@@ -8627,6 +8763,7 @@
           <a:lstStyle/>
           <a:p>
             <a:pPr algn="ctr"/>
+            <a:endParaRPr/>
           </a:p>
         </p:txBody>
       </p:sp>
@@ -8647,7 +8784,7 @@
           <a:noFill/>
         </p:spPr>
         <p:txBody>
-          <a:bodyPr wrap="square" anchor="t" lIns="0" rIns="0" tIns="0" bIns="0">
+          <a:bodyPr wrap="square" lIns="0" tIns="0" rIns="0" bIns="0" anchor="t">
             <a:spAutoFit/>
           </a:bodyPr>
           <a:lstStyle/>
@@ -8692,7 +8829,7 @@
           <a:noFill/>
         </p:spPr>
         <p:txBody>
-          <a:bodyPr wrap="square" anchor="t" lIns="0" rIns="0" tIns="0" bIns="0">
+          <a:bodyPr wrap="square" lIns="0" tIns="0" rIns="0" bIns="0" anchor="t">
             <a:spAutoFit/>
           </a:bodyPr>
           <a:lstStyle/>
@@ -8761,6 +8898,7 @@
           <a:lstStyle/>
           <a:p>
             <a:pPr algn="ctr"/>
+            <a:endParaRPr/>
           </a:p>
         </p:txBody>
       </p:sp>
@@ -8805,6 +8943,7 @@
           <a:lstStyle/>
           <a:p>
             <a:pPr algn="ctr"/>
+            <a:endParaRPr/>
           </a:p>
         </p:txBody>
       </p:sp>
@@ -8825,7 +8964,7 @@
           <a:noFill/>
         </p:spPr>
         <p:txBody>
-          <a:bodyPr wrap="square" anchor="t" lIns="0" rIns="0" tIns="0" bIns="0">
+          <a:bodyPr wrap="square" lIns="0" tIns="0" rIns="0" bIns="0" anchor="t">
             <a:spAutoFit/>
           </a:bodyPr>
           <a:lstStyle/>
@@ -9040,7 +9179,7 @@
 </file>
 
 <file path=ppt/slides/slide15.xml><?xml version="1.0" encoding="utf-8"?>
-<p:sld xmlns:a="http://schemas.openxmlformats.org/drawingml/2006/main" xmlns:p="http://schemas.openxmlformats.org/presentationml/2006/main" xmlns:r="http://schemas.openxmlformats.org/officeDocument/2006/relationships">
+<p:sld xmlns:a="http://schemas.openxmlformats.org/drawingml/2006/main" xmlns:r="http://schemas.openxmlformats.org/officeDocument/2006/relationships" xmlns:p="http://schemas.openxmlformats.org/presentationml/2006/main">
   <p:cSld>
     <p:bg>
       <p:bgPr>
@@ -9056,7 +9195,14 @@
         <p:cNvGrpSpPr/>
         <p:nvPr/>
       </p:nvGrpSpPr>
-      <p:grpSpPr/>
+      <p:grpSpPr>
+        <a:xfrm>
+          <a:off x="0" y="0"/>
+          <a:ext cx="0" cy="0"/>
+          <a:chOff x="0" y="0"/>
+          <a:chExt cx="0" cy="0"/>
+        </a:xfrm>
+      </p:grpSpPr>
       <p:sp>
         <p:nvSpPr>
           <p:cNvPr id="2" name="Rectangle 1"/>
@@ -9098,6 +9244,7 @@
           <a:lstStyle/>
           <a:p>
             <a:pPr algn="ctr"/>
+            <a:endParaRPr/>
           </a:p>
         </p:txBody>
       </p:sp>
@@ -9142,6 +9289,7 @@
           <a:lstStyle/>
           <a:p>
             <a:pPr algn="ctr"/>
+            <a:endParaRPr/>
           </a:p>
         </p:txBody>
       </p:sp>
@@ -9186,6 +9334,7 @@
           <a:lstStyle/>
           <a:p>
             <a:pPr algn="ctr"/>
+            <a:endParaRPr/>
           </a:p>
         </p:txBody>
       </p:sp>
@@ -9206,7 +9355,7 @@
           <a:noFill/>
         </p:spPr>
         <p:txBody>
-          <a:bodyPr wrap="square" anchor="t" lIns="0" rIns="0" tIns="0" bIns="0">
+          <a:bodyPr wrap="square" lIns="0" tIns="0" rIns="0" bIns="0" anchor="t">
             <a:spAutoFit/>
           </a:bodyPr>
           <a:lstStyle/>
@@ -9260,7 +9409,7 @@
           <a:noFill/>
         </p:spPr>
         <p:txBody>
-          <a:bodyPr wrap="square" anchor="t" lIns="0" rIns="0" tIns="0" bIns="0">
+          <a:bodyPr wrap="square" lIns="0" tIns="0" rIns="0" bIns="0" anchor="t">
             <a:spAutoFit/>
           </a:bodyPr>
           <a:lstStyle/>
@@ -9329,6 +9478,7 @@
           <a:lstStyle/>
           <a:p>
             <a:pPr algn="ctr"/>
+            <a:endParaRPr/>
           </a:p>
         </p:txBody>
       </p:sp>
@@ -9349,7 +9499,7 @@
           <a:noFill/>
         </p:spPr>
         <p:txBody>
-          <a:bodyPr wrap="square" anchor="t" lIns="0" rIns="0" tIns="0" bIns="0">
+          <a:bodyPr wrap="square" lIns="0" tIns="0" rIns="0" bIns="0" anchor="t">
             <a:spAutoFit/>
           </a:bodyPr>
           <a:lstStyle/>
@@ -9394,7 +9544,7 @@
           <a:noFill/>
         </p:spPr>
         <p:txBody>
-          <a:bodyPr wrap="square" anchor="t" lIns="0" rIns="0" tIns="0" bIns="0">
+          <a:bodyPr wrap="square" lIns="0" tIns="0" rIns="0" bIns="0" anchor="t">
             <a:spAutoFit/>
           </a:bodyPr>
           <a:lstStyle/>
@@ -9463,6 +9613,7 @@
           <a:lstStyle/>
           <a:p>
             <a:pPr algn="ctr"/>
+            <a:endParaRPr/>
           </a:p>
         </p:txBody>
       </p:sp>
@@ -9507,6 +9658,7 @@
           <a:lstStyle/>
           <a:p>
             <a:pPr algn="ctr"/>
+            <a:endParaRPr/>
           </a:p>
         </p:txBody>
       </p:sp>
@@ -9529,9 +9681,27 @@
                 <a:tableStyleId>{5C22544A-7EE6-4342-B048-85BDC9FD1C3A}</a:tableStyleId>
               </a:tblPr>
               <a:tblGrid>
-                <a:gridCol w="4206240"/>
-                <a:gridCol w="1280160"/>
-                <a:gridCol w="5029200"/>
+                <a:gridCol w="4206240">
+                  <a:extLst>
+                    <a:ext uri="{9D8B030D-6E8A-4147-A177-3AD203B41FA5}">
+                      <a16:colId xmlns:a16="http://schemas.microsoft.com/office/drawing/2014/main" val="20000"/>
+                    </a:ext>
+                  </a:extLst>
+                </a:gridCol>
+                <a:gridCol w="1280160">
+                  <a:extLst>
+                    <a:ext uri="{9D8B030D-6E8A-4147-A177-3AD203B41FA5}">
+                      <a16:colId xmlns:a16="http://schemas.microsoft.com/office/drawing/2014/main" val="20001"/>
+                    </a:ext>
+                  </a:extLst>
+                </a:gridCol>
+                <a:gridCol w="5029200">
+                  <a:extLst>
+                    <a:ext uri="{9D8B030D-6E8A-4147-A177-3AD203B41FA5}">
+                      <a16:colId xmlns:a16="http://schemas.microsoft.com/office/drawing/2014/main" val="20002"/>
+                    </a:ext>
+                  </a:extLst>
+                </a:gridCol>
               </a:tblGrid>
               <a:tr h="475488">
                 <a:tc>
@@ -9603,6 +9773,11 @@
                     </a:solidFill>
                   </a:tcPr>
                 </a:tc>
+                <a:extLst>
+                  <a:ext uri="{0D108BD9-81ED-4DB2-BD59-A6C34878D82A}">
+                    <a16:rowId xmlns:a16="http://schemas.microsoft.com/office/drawing/2014/main" val="10000"/>
+                  </a:ext>
+                </a:extLst>
               </a:tr>
               <a:tr h="621792">
                 <a:tc>
@@ -9674,6 +9849,11 @@
                     </a:solidFill>
                   </a:tcPr>
                 </a:tc>
+                <a:extLst>
+                  <a:ext uri="{0D108BD9-81ED-4DB2-BD59-A6C34878D82A}">
+                    <a16:rowId xmlns:a16="http://schemas.microsoft.com/office/drawing/2014/main" val="10001"/>
+                  </a:ext>
+                </a:extLst>
               </a:tr>
               <a:tr h="621792">
                 <a:tc>
@@ -9745,6 +9925,11 @@
                     </a:solidFill>
                   </a:tcPr>
                 </a:tc>
+                <a:extLst>
+                  <a:ext uri="{0D108BD9-81ED-4DB2-BD59-A6C34878D82A}">
+                    <a16:rowId xmlns:a16="http://schemas.microsoft.com/office/drawing/2014/main" val="10002"/>
+                  </a:ext>
+                </a:extLst>
               </a:tr>
               <a:tr h="621792">
                 <a:tc>
@@ -9816,6 +10001,11 @@
                     </a:solidFill>
                   </a:tcPr>
                 </a:tc>
+                <a:extLst>
+                  <a:ext uri="{0D108BD9-81ED-4DB2-BD59-A6C34878D82A}">
+                    <a16:rowId xmlns:a16="http://schemas.microsoft.com/office/drawing/2014/main" val="10003"/>
+                  </a:ext>
+                </a:extLst>
               </a:tr>
               <a:tr h="621792">
                 <a:tc>
@@ -9887,6 +10077,11 @@
                     </a:solidFill>
                   </a:tcPr>
                 </a:tc>
+                <a:extLst>
+                  <a:ext uri="{0D108BD9-81ED-4DB2-BD59-A6C34878D82A}">
+                    <a16:rowId xmlns:a16="http://schemas.microsoft.com/office/drawing/2014/main" val="10004"/>
+                  </a:ext>
+                </a:extLst>
               </a:tr>
             </a:tbl>
           </a:graphicData>
@@ -9909,7 +10104,7 @@
           <a:noFill/>
         </p:spPr>
         <p:txBody>
-          <a:bodyPr wrap="square" anchor="t" lIns="0" rIns="0" tIns="0" bIns="0">
+          <a:bodyPr wrap="square" lIns="0" tIns="0" rIns="0" bIns="0" anchor="t">
             <a:spAutoFit/>
           </a:bodyPr>
           <a:lstStyle/>
@@ -9946,7 +10141,7 @@
 </file>
 
 <file path=ppt/slides/slide16.xml><?xml version="1.0" encoding="utf-8"?>
-<p:sld xmlns:a="http://schemas.openxmlformats.org/drawingml/2006/main" xmlns:p="http://schemas.openxmlformats.org/presentationml/2006/main" xmlns:r="http://schemas.openxmlformats.org/officeDocument/2006/relationships">
+<p:sld xmlns:a="http://schemas.openxmlformats.org/drawingml/2006/main" xmlns:r="http://schemas.openxmlformats.org/officeDocument/2006/relationships" xmlns:p="http://schemas.openxmlformats.org/presentationml/2006/main">
   <p:cSld>
     <p:bg>
       <p:bgPr>
@@ -9962,7 +10157,14 @@
         <p:cNvGrpSpPr/>
         <p:nvPr/>
       </p:nvGrpSpPr>
-      <p:grpSpPr/>
+      <p:grpSpPr>
+        <a:xfrm>
+          <a:off x="0" y="0"/>
+          <a:ext cx="0" cy="0"/>
+          <a:chOff x="0" y="0"/>
+          <a:chExt cx="0" cy="0"/>
+        </a:xfrm>
+      </p:grpSpPr>
       <p:sp>
         <p:nvSpPr>
           <p:cNvPr id="2" name="Rectangle 1"/>
@@ -10004,6 +10206,7 @@
           <a:lstStyle/>
           <a:p>
             <a:pPr algn="ctr"/>
+            <a:endParaRPr/>
           </a:p>
         </p:txBody>
       </p:sp>
@@ -10048,6 +10251,7 @@
           <a:lstStyle/>
           <a:p>
             <a:pPr algn="ctr"/>
+            <a:endParaRPr/>
           </a:p>
         </p:txBody>
       </p:sp>
@@ -10092,6 +10296,7 @@
           <a:lstStyle/>
           <a:p>
             <a:pPr algn="ctr"/>
+            <a:endParaRPr/>
           </a:p>
         </p:txBody>
       </p:sp>
@@ -10136,6 +10341,7 @@
           <a:lstStyle/>
           <a:p>
             <a:pPr algn="ctr"/>
+            <a:endParaRPr/>
           </a:p>
         </p:txBody>
       </p:sp>
@@ -10180,6 +10386,7 @@
           <a:lstStyle/>
           <a:p>
             <a:pPr algn="ctr"/>
+            <a:endParaRPr/>
           </a:p>
         </p:txBody>
       </p:sp>
@@ -10200,7 +10407,7 @@
           <a:noFill/>
         </p:spPr>
         <p:txBody>
-          <a:bodyPr wrap="square" anchor="t" lIns="0" rIns="0" tIns="0" bIns="0">
+          <a:bodyPr wrap="square" lIns="0" tIns="0" rIns="0" bIns="0" anchor="t">
             <a:spAutoFit/>
           </a:bodyPr>
           <a:lstStyle/>
@@ -10245,7 +10452,7 @@
           <a:noFill/>
         </p:spPr>
         <p:txBody>
-          <a:bodyPr wrap="square" anchor="t" lIns="0" rIns="0" tIns="0" bIns="0">
+          <a:bodyPr wrap="square" lIns="0" tIns="0" rIns="0" bIns="0" anchor="t">
             <a:spAutoFit/>
           </a:bodyPr>
           <a:lstStyle/>
@@ -10262,7 +10469,7 @@
               </a:spcAft>
             </a:pPr>
             <a:r>
-              <a:rPr sz="3400" b="1">
+              <a:rPr sz="3400" b="1" dirty="0">
                 <a:solidFill>
                   <a:srgbClr val="EAF3EF"/>
                 </a:solidFill>
@@ -10284,7 +10491,7 @@
               </a:spcAft>
             </a:pPr>
             <a:r>
-              <a:rPr sz="3400" b="1">
+              <a:rPr sz="3400" b="1" dirty="0">
                 <a:solidFill>
                   <a:srgbClr val="EAF3EF"/>
                 </a:solidFill>
@@ -10336,6 +10543,7 @@
           <a:lstStyle/>
           <a:p>
             <a:pPr algn="ctr"/>
+            <a:endParaRPr/>
           </a:p>
         </p:txBody>
       </p:sp>
@@ -10356,7 +10564,7 @@
           <a:noFill/>
         </p:spPr>
         <p:txBody>
-          <a:bodyPr wrap="square" anchor="t" lIns="0" rIns="0" tIns="0" bIns="0">
+          <a:bodyPr wrap="square" lIns="0" tIns="0" rIns="0" bIns="0" anchor="t">
             <a:spAutoFit/>
           </a:bodyPr>
           <a:lstStyle/>
@@ -10401,7 +10609,7 @@
           <a:noFill/>
         </p:spPr>
         <p:txBody>
-          <a:bodyPr wrap="square" anchor="t" lIns="0" rIns="0" tIns="0" bIns="0">
+          <a:bodyPr wrap="square" lIns="0" tIns="0" rIns="0" bIns="0" anchor="t">
             <a:spAutoFit/>
           </a:bodyPr>
           <a:lstStyle/>
@@ -10418,7 +10626,7 @@
               </a:spcAft>
             </a:pPr>
             <a:r>
-              <a:rPr sz="1300" b="1">
+              <a:rPr sz="1300" b="1" dirty="0">
                 <a:solidFill>
                   <a:srgbClr val="5C726A"/>
                 </a:solidFill>
@@ -10427,14 +10635,47 @@
               <a:t>Source    </a:t>
             </a:r>
             <a:r>
-              <a:rPr sz="1300" b="0">
+              <a:rPr sz="1300" b="0" dirty="0">
                 <a:solidFill>
                   <a:srgbClr val="00E676"/>
                 </a:solidFill>
                 <a:latin typeface="Consolas"/>
               </a:rPr>
-              <a:t>github.com/moneytosms/offlineid</a:t>
-            </a:r>
+              <a:t>github.com/</a:t>
+            </a:r>
+            <a:r>
+              <a:rPr sz="1300" b="0" dirty="0" err="1">
+                <a:solidFill>
+                  <a:srgbClr val="00E676"/>
+                </a:solidFill>
+                <a:latin typeface="Consolas"/>
+              </a:rPr>
+              <a:t>moneytosms</a:t>
+            </a:r>
+            <a:r>
+              <a:rPr sz="1300" b="0" dirty="0">
+                <a:solidFill>
+                  <a:srgbClr val="00E676"/>
+                </a:solidFill>
+                <a:latin typeface="Consolas"/>
+              </a:rPr>
+              <a:t>/</a:t>
+            </a:r>
+            <a:r>
+              <a:rPr sz="1300" b="0" dirty="0" err="1">
+                <a:solidFill>
+                  <a:srgbClr val="00E676"/>
+                </a:solidFill>
+                <a:latin typeface="Consolas"/>
+              </a:rPr>
+              <a:t>offlineid</a:t>
+            </a:r>
+            <a:endParaRPr sz="1300" b="0" dirty="0">
+              <a:solidFill>
+                <a:srgbClr val="00E676"/>
+              </a:solidFill>
+              <a:latin typeface="Consolas"/>
+            </a:endParaRPr>
           </a:p>
           <a:p>
             <a:pPr algn="l">
@@ -10449,7 +10690,7 @@
               </a:spcAft>
             </a:pPr>
             <a:r>
-              <a:rPr sz="1300" b="1">
+              <a:rPr sz="1300" b="1" dirty="0">
                 <a:solidFill>
                   <a:srgbClr val="5C726A"/>
                 </a:solidFill>
@@ -10458,27 +10699,363 @@
               <a:t>Release   </a:t>
             </a:r>
             <a:r>
-              <a:rPr sz="1300" b="0">
+              <a:rPr sz="1300" b="0" dirty="0">
                 <a:solidFill>
                   <a:srgbClr val="00E676"/>
                 </a:solidFill>
                 <a:latin typeface="Consolas"/>
               </a:rPr>
-              <a:t>github.com/moneytosms/offlineid/releases/tag/v1.0.0</a:t>
-            </a:r>
-          </a:p>
-        </p:txBody>
-      </p:sp>
-      <p:sp>
-        <p:nvSpPr>
-          <p:cNvPr id="12" name="TextBox 11"/>
+              <a:t>github.com/</a:t>
+            </a:r>
+            <a:r>
+              <a:rPr sz="1300" b="0" dirty="0" err="1">
+                <a:solidFill>
+                  <a:srgbClr val="00E676"/>
+                </a:solidFill>
+                <a:latin typeface="Consolas"/>
+              </a:rPr>
+              <a:t>moneytosms</a:t>
+            </a:r>
+            <a:r>
+              <a:rPr sz="1300" b="0" dirty="0">
+                <a:solidFill>
+                  <a:srgbClr val="00E676"/>
+                </a:solidFill>
+                <a:latin typeface="Consolas"/>
+              </a:rPr>
+              <a:t>/</a:t>
+            </a:r>
+            <a:r>
+              <a:rPr sz="1300" b="0" dirty="0" err="1">
+                <a:solidFill>
+                  <a:srgbClr val="00E676"/>
+                </a:solidFill>
+                <a:latin typeface="Consolas"/>
+              </a:rPr>
+              <a:t>offlineid</a:t>
+            </a:r>
+            <a:r>
+              <a:rPr sz="1300" b="0" dirty="0">
+                <a:solidFill>
+                  <a:srgbClr val="00E676"/>
+                </a:solidFill>
+                <a:latin typeface="Consolas"/>
+              </a:rPr>
+              <a:t>/releases/tag/v1.1.0</a:t>
+            </a:r>
+          </a:p>
+        </p:txBody>
+      </p:sp>
+    </p:spTree>
+  </p:cSld>
+  <p:clrMapOvr>
+    <a:masterClrMapping/>
+  </p:clrMapOvr>
+</p:sld>
+</file>
+
+<file path=ppt/slides/slide17.xml><?xml version="1.0" encoding="utf-8"?>
+<p:sld xmlns:a="http://schemas.openxmlformats.org/drawingml/2006/main" xmlns:r="http://schemas.openxmlformats.org/officeDocument/2006/relationships" xmlns:p="http://schemas.openxmlformats.org/presentationml/2006/main">
+  <p:cSld>
+    <p:bg>
+      <p:bgPr>
+        <a:solidFill>
+          <a:srgbClr val="0A0E0D"/>
+        </a:solidFill>
+        <a:effectLst/>
+      </p:bgPr>
+    </p:bg>
+    <p:spTree>
+      <p:nvGrpSpPr>
+        <p:cNvPr id="1" name="">
+          <a:extLst>
+            <a:ext uri="{FF2B5EF4-FFF2-40B4-BE49-F238E27FC236}">
+              <a16:creationId xmlns:a16="http://schemas.microsoft.com/office/drawing/2014/main" id="{FEFD81DD-C49B-E7E0-8728-F83D1B42BA7F}"/>
+            </a:ext>
+          </a:extLst>
+        </p:cNvPr>
+        <p:cNvGrpSpPr/>
+        <p:nvPr/>
+      </p:nvGrpSpPr>
+      <p:grpSpPr>
+        <a:xfrm>
+          <a:off x="0" y="0"/>
+          <a:ext cx="0" cy="0"/>
+          <a:chOff x="0" y="0"/>
+          <a:chExt cx="0" cy="0"/>
+        </a:xfrm>
+      </p:grpSpPr>
+      <p:sp>
+        <p:nvSpPr>
+          <p:cNvPr id="2" name="Rectangle 1">
+            <a:extLst>
+              <a:ext uri="{FF2B5EF4-FFF2-40B4-BE49-F238E27FC236}">
+                <a16:creationId xmlns:a16="http://schemas.microsoft.com/office/drawing/2014/main" id="{E4A7094E-049C-1451-1A34-C8B3C84A2ECF}"/>
+              </a:ext>
+            </a:extLst>
+          </p:cNvPr>
+          <p:cNvSpPr/>
+          <p:nvPr/>
+        </p:nvSpPr>
+        <p:spPr>
+          <a:xfrm>
+            <a:off x="0" y="0"/>
+            <a:ext cx="109728" cy="6858000"/>
+          </a:xfrm>
+          <a:prstGeom prst="rect">
+            <a:avLst/>
+          </a:prstGeom>
+          <a:solidFill>
+            <a:srgbClr val="00E676"/>
+          </a:solidFill>
+          <a:ln>
+            <a:noFill/>
+          </a:ln>
+          <a:effectLst/>
+        </p:spPr>
+        <p:style>
+          <a:lnRef idx="1">
+            <a:schemeClr val="accent1"/>
+          </a:lnRef>
+          <a:fillRef idx="3">
+            <a:schemeClr val="accent1"/>
+          </a:fillRef>
+          <a:effectRef idx="2">
+            <a:schemeClr val="accent1"/>
+          </a:effectRef>
+          <a:fontRef idx="minor">
+            <a:schemeClr val="lt1"/>
+          </a:fontRef>
+        </p:style>
+        <p:txBody>
+          <a:bodyPr rtlCol="0" anchor="ctr"/>
+          <a:lstStyle/>
+          <a:p>
+            <a:pPr algn="ctr"/>
+            <a:endParaRPr/>
+          </a:p>
+        </p:txBody>
+      </p:sp>
+      <p:sp>
+        <p:nvSpPr>
+          <p:cNvPr id="3" name="Rectangle 2">
+            <a:extLst>
+              <a:ext uri="{FF2B5EF4-FFF2-40B4-BE49-F238E27FC236}">
+                <a16:creationId xmlns:a16="http://schemas.microsoft.com/office/drawing/2014/main" id="{0B69AFA6-AF8B-202A-50CF-9CD965EE53B0}"/>
+              </a:ext>
+            </a:extLst>
+          </p:cNvPr>
+          <p:cNvSpPr/>
+          <p:nvPr/>
+        </p:nvSpPr>
+        <p:spPr>
+          <a:xfrm>
+            <a:off x="0" y="6748272"/>
+            <a:ext cx="12191695" cy="109728"/>
+          </a:xfrm>
+          <a:prstGeom prst="rect">
+            <a:avLst/>
+          </a:prstGeom>
+          <a:solidFill>
+            <a:srgbClr val="00E676"/>
+          </a:solidFill>
+          <a:ln>
+            <a:noFill/>
+          </a:ln>
+          <a:effectLst/>
+        </p:spPr>
+        <p:style>
+          <a:lnRef idx="1">
+            <a:schemeClr val="accent1"/>
+          </a:lnRef>
+          <a:fillRef idx="3">
+            <a:schemeClr val="accent1"/>
+          </a:fillRef>
+          <a:effectRef idx="2">
+            <a:schemeClr val="accent1"/>
+          </a:effectRef>
+          <a:fontRef idx="minor">
+            <a:schemeClr val="lt1"/>
+          </a:fontRef>
+        </p:style>
+        <p:txBody>
+          <a:bodyPr rtlCol="0" anchor="ctr"/>
+          <a:lstStyle/>
+          <a:p>
+            <a:pPr algn="ctr"/>
+            <a:endParaRPr/>
+          </a:p>
+        </p:txBody>
+      </p:sp>
+      <p:sp>
+        <p:nvSpPr>
+          <p:cNvPr id="4" name="Rectangle 3">
+            <a:extLst>
+              <a:ext uri="{FF2B5EF4-FFF2-40B4-BE49-F238E27FC236}">
+                <a16:creationId xmlns:a16="http://schemas.microsoft.com/office/drawing/2014/main" id="{70BDB871-AE93-4C87-9B09-73A96081E460}"/>
+              </a:ext>
+            </a:extLst>
+          </p:cNvPr>
+          <p:cNvSpPr/>
+          <p:nvPr/>
+        </p:nvSpPr>
+        <p:spPr>
+          <a:xfrm>
+            <a:off x="11185855" y="6748272"/>
+            <a:ext cx="1005840" cy="109728"/>
+          </a:xfrm>
+          <a:prstGeom prst="rect">
+            <a:avLst/>
+          </a:prstGeom>
+          <a:solidFill>
+            <a:srgbClr val="00E676"/>
+          </a:solidFill>
+          <a:ln>
+            <a:noFill/>
+          </a:ln>
+          <a:effectLst/>
+        </p:spPr>
+        <p:style>
+          <a:lnRef idx="1">
+            <a:schemeClr val="accent1"/>
+          </a:lnRef>
+          <a:fillRef idx="3">
+            <a:schemeClr val="accent1"/>
+          </a:fillRef>
+          <a:effectRef idx="2">
+            <a:schemeClr val="accent1"/>
+          </a:effectRef>
+          <a:fontRef idx="minor">
+            <a:schemeClr val="lt1"/>
+          </a:fontRef>
+        </p:style>
+        <p:txBody>
+          <a:bodyPr rtlCol="0" anchor="ctr"/>
+          <a:lstStyle/>
+          <a:p>
+            <a:pPr algn="ctr"/>
+            <a:endParaRPr/>
+          </a:p>
+        </p:txBody>
+      </p:sp>
+      <p:sp>
+        <p:nvSpPr>
+          <p:cNvPr id="5" name="Rectangle 4">
+            <a:extLst>
+              <a:ext uri="{FF2B5EF4-FFF2-40B4-BE49-F238E27FC236}">
+                <a16:creationId xmlns:a16="http://schemas.microsoft.com/office/drawing/2014/main" id="{A58686CB-EAC9-2BB3-84F3-54F6760DD7BD}"/>
+              </a:ext>
+            </a:extLst>
+          </p:cNvPr>
+          <p:cNvSpPr/>
+          <p:nvPr/>
+        </p:nvSpPr>
+        <p:spPr>
+          <a:xfrm>
+            <a:off x="12081967" y="5852160"/>
+            <a:ext cx="109728" cy="1005840"/>
+          </a:xfrm>
+          <a:prstGeom prst="rect">
+            <a:avLst/>
+          </a:prstGeom>
+          <a:solidFill>
+            <a:srgbClr val="00E676"/>
+          </a:solidFill>
+          <a:ln>
+            <a:noFill/>
+          </a:ln>
+          <a:effectLst/>
+        </p:spPr>
+        <p:style>
+          <a:lnRef idx="1">
+            <a:schemeClr val="accent1"/>
+          </a:lnRef>
+          <a:fillRef idx="3">
+            <a:schemeClr val="accent1"/>
+          </a:fillRef>
+          <a:effectRef idx="2">
+            <a:schemeClr val="accent1"/>
+          </a:effectRef>
+          <a:fontRef idx="minor">
+            <a:schemeClr val="lt1"/>
+          </a:fontRef>
+        </p:style>
+        <p:txBody>
+          <a:bodyPr rtlCol="0" anchor="ctr"/>
+          <a:lstStyle/>
+          <a:p>
+            <a:pPr algn="ctr"/>
+            <a:endParaRPr/>
+          </a:p>
+        </p:txBody>
+      </p:sp>
+      <p:sp>
+        <p:nvSpPr>
+          <p:cNvPr id="6" name="Rectangle 5">
+            <a:extLst>
+              <a:ext uri="{FF2B5EF4-FFF2-40B4-BE49-F238E27FC236}">
+                <a16:creationId xmlns:a16="http://schemas.microsoft.com/office/drawing/2014/main" id="{361DB518-F8EA-3E14-CA99-751BC951045E}"/>
+              </a:ext>
+            </a:extLst>
+          </p:cNvPr>
+          <p:cNvSpPr/>
+          <p:nvPr/>
+        </p:nvSpPr>
+        <p:spPr>
+          <a:xfrm flipH="1">
+            <a:off x="850392" y="502920"/>
+            <a:ext cx="45719" cy="310896"/>
+          </a:xfrm>
+          <a:prstGeom prst="rect">
+            <a:avLst/>
+          </a:prstGeom>
+          <a:solidFill>
+            <a:srgbClr val="00E676"/>
+          </a:solidFill>
+          <a:ln>
+            <a:noFill/>
+          </a:ln>
+          <a:effectLst/>
+        </p:spPr>
+        <p:style>
+          <a:lnRef idx="1">
+            <a:schemeClr val="accent1"/>
+          </a:lnRef>
+          <a:fillRef idx="3">
+            <a:schemeClr val="accent1"/>
+          </a:fillRef>
+          <a:effectRef idx="2">
+            <a:schemeClr val="accent1"/>
+          </a:effectRef>
+          <a:fontRef idx="minor">
+            <a:schemeClr val="lt1"/>
+          </a:fontRef>
+        </p:style>
+        <p:txBody>
+          <a:bodyPr rtlCol="0" anchor="ctr"/>
+          <a:lstStyle/>
+          <a:p>
+            <a:pPr algn="ctr"/>
+            <a:endParaRPr/>
+          </a:p>
+        </p:txBody>
+      </p:sp>
+      <p:sp>
+        <p:nvSpPr>
+          <p:cNvPr id="7" name="TextBox 6">
+            <a:extLst>
+              <a:ext uri="{FF2B5EF4-FFF2-40B4-BE49-F238E27FC236}">
+                <a16:creationId xmlns:a16="http://schemas.microsoft.com/office/drawing/2014/main" id="{D29F3190-1125-BA1A-762B-97BAEB12EDB5}"/>
+              </a:ext>
+            </a:extLst>
+          </p:cNvPr>
           <p:cNvSpPr txBox="1"/>
           <p:nvPr/>
         </p:nvSpPr>
         <p:spPr>
           <a:xfrm>
-            <a:off x="822960" y="5897880"/>
-            <a:ext cx="10515600" cy="457200"/>
+            <a:off x="1024128" y="502920"/>
+            <a:ext cx="10515600" cy="246221"/>
           </a:xfrm>
           <a:prstGeom prst="rect">
             <a:avLst/>
@@ -10486,7 +11063,7 @@
           <a:noFill/>
         </p:spPr>
         <p:txBody>
-          <a:bodyPr wrap="square" anchor="t" lIns="0" rIns="0" tIns="0" bIns="0">
+          <a:bodyPr wrap="square" lIns="0" tIns="0" rIns="0" bIns="0" anchor="t">
             <a:spAutoFit/>
           </a:bodyPr>
           <a:lstStyle/>
@@ -10503,18 +11080,294 @@
               </a:spcAft>
             </a:pPr>
             <a:r>
-              <a:rPr sz="1500" b="1">
+              <a:rPr sz="1600" b="1" dirty="0">
+                <a:solidFill>
+                  <a:srgbClr val="00E676"/>
+                </a:solidFill>
+                <a:latin typeface="Consolas"/>
+              </a:rPr>
+              <a:t>OFFLINE·ID</a:t>
+            </a:r>
+          </a:p>
+        </p:txBody>
+      </p:sp>
+      <p:sp>
+        <p:nvSpPr>
+          <p:cNvPr id="9" name="Rectangle 8">
+            <a:extLst>
+              <a:ext uri="{FF2B5EF4-FFF2-40B4-BE49-F238E27FC236}">
+                <a16:creationId xmlns:a16="http://schemas.microsoft.com/office/drawing/2014/main" id="{FDF1D2F2-4DFA-F45F-7BC3-DAB593B885A3}"/>
+              </a:ext>
+            </a:extLst>
+          </p:cNvPr>
+          <p:cNvSpPr/>
+          <p:nvPr/>
+        </p:nvSpPr>
+        <p:spPr>
+          <a:xfrm>
+            <a:off x="822960" y="922877"/>
+            <a:ext cx="1828800" cy="45720"/>
+          </a:xfrm>
+          <a:prstGeom prst="rect">
+            <a:avLst/>
+          </a:prstGeom>
+          <a:solidFill>
+            <a:srgbClr val="00E676"/>
+          </a:solidFill>
+          <a:ln>
+            <a:noFill/>
+          </a:ln>
+          <a:effectLst/>
+        </p:spPr>
+        <p:style>
+          <a:lnRef idx="1">
+            <a:schemeClr val="accent1"/>
+          </a:lnRef>
+          <a:fillRef idx="3">
+            <a:schemeClr val="accent1"/>
+          </a:fillRef>
+          <a:effectRef idx="2">
+            <a:schemeClr val="accent1"/>
+          </a:effectRef>
+          <a:fontRef idx="minor">
+            <a:schemeClr val="lt1"/>
+          </a:fontRef>
+        </p:style>
+        <p:txBody>
+          <a:bodyPr rtlCol="0" anchor="ctr"/>
+          <a:lstStyle/>
+          <a:p>
+            <a:pPr algn="ctr"/>
+            <a:endParaRPr/>
+          </a:p>
+        </p:txBody>
+      </p:sp>
+      <p:sp>
+        <p:nvSpPr>
+          <p:cNvPr id="12" name="TextBox 11">
+            <a:extLst>
+              <a:ext uri="{FF2B5EF4-FFF2-40B4-BE49-F238E27FC236}">
+                <a16:creationId xmlns:a16="http://schemas.microsoft.com/office/drawing/2014/main" id="{102FB7E6-F9E4-843C-B021-15991EDB5227}"/>
+              </a:ext>
+            </a:extLst>
+          </p:cNvPr>
+          <p:cNvSpPr txBox="1"/>
+          <p:nvPr/>
+        </p:nvSpPr>
+        <p:spPr>
+          <a:xfrm>
+            <a:off x="822960" y="5897880"/>
+            <a:ext cx="10515600" cy="512961"/>
+          </a:xfrm>
+          <a:prstGeom prst="rect">
+            <a:avLst/>
+          </a:prstGeom>
+          <a:noFill/>
+        </p:spPr>
+        <p:txBody>
+          <a:bodyPr wrap="square" lIns="0" tIns="0" rIns="0" bIns="0" anchor="t">
+            <a:spAutoFit/>
+          </a:bodyPr>
+          <a:lstStyle/>
+          <a:p>
+            <a:pPr algn="l">
+              <a:lnSpc>
+                <a:spcPct val="100000"/>
+              </a:lnSpc>
+              <a:spcBef>
+                <a:spcPts val="0"/>
+              </a:spcBef>
+              <a:spcAft>
+                <a:spcPts val="400"/>
+              </a:spcAft>
+            </a:pPr>
+            <a:r>
+              <a:rPr sz="1500" b="1" dirty="0">
                 <a:solidFill>
                   <a:srgbClr val="EAF3EF"/>
                 </a:solidFill>
                 <a:latin typeface="Segoe UI"/>
               </a:rPr>
-              <a:t>Thank you   ·   Q &amp; A</a:t>
+              <a:t>Thank you   ·</a:t>
+            </a:r>
+            <a:endParaRPr lang="en-IN" sz="1500" b="1" dirty="0">
+              <a:solidFill>
+                <a:srgbClr val="EAF3EF"/>
+              </a:solidFill>
+              <a:latin typeface="Segoe UI"/>
+            </a:endParaRPr>
+          </a:p>
+          <a:p>
+            <a:pPr algn="l">
+              <a:lnSpc>
+                <a:spcPct val="100000"/>
+              </a:lnSpc>
+              <a:spcBef>
+                <a:spcPts val="0"/>
+              </a:spcBef>
+              <a:spcAft>
+                <a:spcPts val="400"/>
+              </a:spcAft>
+            </a:pPr>
+            <a:endParaRPr sz="1500" b="1" dirty="0">
+              <a:solidFill>
+                <a:srgbClr val="EAF3EF"/>
+              </a:solidFill>
+              <a:latin typeface="Segoe UI"/>
+            </a:endParaRPr>
+          </a:p>
+        </p:txBody>
+      </p:sp>
+      <p:sp>
+        <p:nvSpPr>
+          <p:cNvPr id="13" name="TextBox 12">
+            <a:extLst>
+              <a:ext uri="{FF2B5EF4-FFF2-40B4-BE49-F238E27FC236}">
+                <a16:creationId xmlns:a16="http://schemas.microsoft.com/office/drawing/2014/main" id="{E60432CB-E180-5F2B-22DE-57A20E3F4419}"/>
+              </a:ext>
+            </a:extLst>
+          </p:cNvPr>
+          <p:cNvSpPr txBox="1"/>
+          <p:nvPr/>
+        </p:nvSpPr>
+        <p:spPr>
+          <a:xfrm>
+            <a:off x="822960" y="1207008"/>
+            <a:ext cx="5905527" cy="615553"/>
+          </a:xfrm>
+          <a:prstGeom prst="rect">
+            <a:avLst/>
+          </a:prstGeom>
+          <a:noFill/>
+        </p:spPr>
+        <p:txBody>
+          <a:bodyPr wrap="none" rtlCol="0">
+            <a:spAutoFit/>
+          </a:bodyPr>
+          <a:lstStyle/>
+          <a:p>
+            <a:r>
+              <a:rPr lang="en-IN" sz="3400" u="sng" dirty="0">
+                <a:solidFill>
+                  <a:schemeClr val="bg2"/>
+                </a:solidFill>
+                <a:latin typeface="Segoe UI" panose="020B0502040204020203" pitchFamily="34" charset="0"/>
+                <a:cs typeface="Segoe UI" panose="020B0502040204020203" pitchFamily="34" charset="0"/>
+              </a:rPr>
+              <a:t>Submitted by: Team </a:t>
+            </a:r>
+            <a:r>
+              <a:rPr lang="en-IN" sz="3400" b="1" i="1" u="sng" dirty="0">
+                <a:solidFill>
+                  <a:schemeClr val="bg2"/>
+                </a:solidFill>
+                <a:latin typeface="Segoe UI" panose="020B0502040204020203" pitchFamily="34" charset="0"/>
+                <a:cs typeface="Segoe UI" panose="020B0502040204020203" pitchFamily="34" charset="0"/>
+              </a:rPr>
+              <a:t>Optional</a:t>
+            </a:r>
+          </a:p>
+        </p:txBody>
+      </p:sp>
+      <p:sp>
+        <p:nvSpPr>
+          <p:cNvPr id="14" name="TextBox 13">
+            <a:extLst>
+              <a:ext uri="{FF2B5EF4-FFF2-40B4-BE49-F238E27FC236}">
+                <a16:creationId xmlns:a16="http://schemas.microsoft.com/office/drawing/2014/main" id="{50504ED5-A037-F7B0-64D5-776075208A21}"/>
+              </a:ext>
+            </a:extLst>
+          </p:cNvPr>
+          <p:cNvSpPr txBox="1"/>
+          <p:nvPr/>
+        </p:nvSpPr>
+        <p:spPr>
+          <a:xfrm>
+            <a:off x="2031339" y="2303954"/>
+            <a:ext cx="7232904" cy="2062103"/>
+          </a:xfrm>
+          <a:prstGeom prst="rect">
+            <a:avLst/>
+          </a:prstGeom>
+          <a:noFill/>
+        </p:spPr>
+        <p:txBody>
+          <a:bodyPr wrap="square" rtlCol="0">
+            <a:spAutoFit/>
+          </a:bodyPr>
+          <a:lstStyle/>
+          <a:p>
+            <a:pPr marL="342900" indent="-342900">
+              <a:buFont typeface="+mj-lt"/>
+              <a:buAutoNum type="arabicPeriod"/>
+            </a:pPr>
+            <a:r>
+              <a:rPr lang="en-IN" sz="3200" dirty="0">
+                <a:solidFill>
+                  <a:schemeClr val="bg1"/>
+                </a:solidFill>
+                <a:latin typeface="Segoe UI" panose="020B0502040204020203" pitchFamily="34" charset="0"/>
+                <a:cs typeface="Segoe UI" panose="020B0502040204020203" pitchFamily="34" charset="0"/>
+              </a:rPr>
+              <a:t>Srimoneyshankar Ajith</a:t>
+            </a:r>
+          </a:p>
+          <a:p>
+            <a:pPr marL="342900" indent="-342900">
+              <a:buFont typeface="+mj-lt"/>
+              <a:buAutoNum type="arabicPeriod"/>
+            </a:pPr>
+            <a:r>
+              <a:rPr lang="en-IN" sz="3200" dirty="0">
+                <a:solidFill>
+                  <a:schemeClr val="bg1"/>
+                </a:solidFill>
+                <a:latin typeface="Segoe UI" panose="020B0502040204020203" pitchFamily="34" charset="0"/>
+                <a:cs typeface="Segoe UI" panose="020B0502040204020203" pitchFamily="34" charset="0"/>
+              </a:rPr>
+              <a:t>Akshay V.S</a:t>
+            </a:r>
+          </a:p>
+          <a:p>
+            <a:pPr marL="342900" indent="-342900">
+              <a:buFont typeface="+mj-lt"/>
+              <a:buAutoNum type="arabicPeriod"/>
+            </a:pPr>
+            <a:r>
+              <a:rPr lang="en-IN" sz="3200" dirty="0">
+                <a:solidFill>
+                  <a:schemeClr val="bg1"/>
+                </a:solidFill>
+                <a:latin typeface="Segoe UI" panose="020B0502040204020203" pitchFamily="34" charset="0"/>
+                <a:cs typeface="Segoe UI" panose="020B0502040204020203" pitchFamily="34" charset="0"/>
+              </a:rPr>
+              <a:t>Nidhi Rakesh</a:t>
+            </a:r>
+          </a:p>
+          <a:p>
+            <a:pPr marL="342900" indent="-342900">
+              <a:buFont typeface="+mj-lt"/>
+              <a:buAutoNum type="arabicPeriod"/>
+            </a:pPr>
+            <a:r>
+              <a:rPr lang="en-IN" sz="3200" dirty="0">
+                <a:solidFill>
+                  <a:schemeClr val="bg1"/>
+                </a:solidFill>
+                <a:latin typeface="Segoe UI" panose="020B0502040204020203" pitchFamily="34" charset="0"/>
+                <a:cs typeface="Segoe UI" panose="020B0502040204020203" pitchFamily="34" charset="0"/>
+              </a:rPr>
+              <a:t>Bharadwaj B Chand</a:t>
             </a:r>
           </a:p>
         </p:txBody>
       </p:sp>
     </p:spTree>
+    <p:extLst>
+      <p:ext uri="{BB962C8B-B14F-4D97-AF65-F5344CB8AC3E}">
+        <p14:creationId xmlns:p14="http://schemas.microsoft.com/office/powerpoint/2010/main" val="2597690401"/>
+      </p:ext>
+    </p:extLst>
   </p:cSld>
   <p:clrMapOvr>
     <a:masterClrMapping/>
@@ -10523,7 +11376,7 @@
 </file>
 
 <file path=ppt/slides/slide2.xml><?xml version="1.0" encoding="utf-8"?>
-<p:sld xmlns:a="http://schemas.openxmlformats.org/drawingml/2006/main" xmlns:p="http://schemas.openxmlformats.org/presentationml/2006/main" xmlns:r="http://schemas.openxmlformats.org/officeDocument/2006/relationships">
+<p:sld xmlns:a="http://schemas.openxmlformats.org/drawingml/2006/main" xmlns:r="http://schemas.openxmlformats.org/officeDocument/2006/relationships" xmlns:p="http://schemas.openxmlformats.org/presentationml/2006/main">
   <p:cSld>
     <p:bg>
       <p:bgPr>
@@ -10539,7 +11392,14 @@
         <p:cNvGrpSpPr/>
         <p:nvPr/>
       </p:nvGrpSpPr>
-      <p:grpSpPr/>
+      <p:grpSpPr>
+        <a:xfrm>
+          <a:off x="0" y="0"/>
+          <a:ext cx="0" cy="0"/>
+          <a:chOff x="0" y="0"/>
+          <a:chExt cx="0" cy="0"/>
+        </a:xfrm>
+      </p:grpSpPr>
       <p:sp>
         <p:nvSpPr>
           <p:cNvPr id="2" name="Rectangle 1"/>
@@ -10581,6 +11441,7 @@
           <a:lstStyle/>
           <a:p>
             <a:pPr algn="ctr"/>
+            <a:endParaRPr/>
           </a:p>
         </p:txBody>
       </p:sp>
@@ -10625,6 +11486,7 @@
           <a:lstStyle/>
           <a:p>
             <a:pPr algn="ctr"/>
+            <a:endParaRPr/>
           </a:p>
         </p:txBody>
       </p:sp>
@@ -10669,6 +11531,7 @@
           <a:lstStyle/>
           <a:p>
             <a:pPr algn="ctr"/>
+            <a:endParaRPr/>
           </a:p>
         </p:txBody>
       </p:sp>
@@ -10689,7 +11552,7 @@
           <a:noFill/>
         </p:spPr>
         <p:txBody>
-          <a:bodyPr wrap="square" anchor="t" lIns="0" rIns="0" tIns="0" bIns="0">
+          <a:bodyPr wrap="square" lIns="0" tIns="0" rIns="0" bIns="0" anchor="t">
             <a:spAutoFit/>
           </a:bodyPr>
           <a:lstStyle/>
@@ -10743,7 +11606,7 @@
           <a:noFill/>
         </p:spPr>
         <p:txBody>
-          <a:bodyPr wrap="square" anchor="t" lIns="0" rIns="0" tIns="0" bIns="0">
+          <a:bodyPr wrap="square" lIns="0" tIns="0" rIns="0" bIns="0" anchor="t">
             <a:spAutoFit/>
           </a:bodyPr>
           <a:lstStyle/>
@@ -10812,6 +11675,7 @@
           <a:lstStyle/>
           <a:p>
             <a:pPr algn="ctr"/>
+            <a:endParaRPr/>
           </a:p>
         </p:txBody>
       </p:sp>
@@ -10832,7 +11696,7 @@
           <a:noFill/>
         </p:spPr>
         <p:txBody>
-          <a:bodyPr wrap="square" anchor="t" lIns="0" rIns="0" tIns="0" bIns="0">
+          <a:bodyPr wrap="square" lIns="0" tIns="0" rIns="0" bIns="0" anchor="t">
             <a:spAutoFit/>
           </a:bodyPr>
           <a:lstStyle/>
@@ -10877,7 +11741,7 @@
           <a:noFill/>
         </p:spPr>
         <p:txBody>
-          <a:bodyPr wrap="square" anchor="t" lIns="0" rIns="0" tIns="0" bIns="0">
+          <a:bodyPr wrap="square" lIns="0" tIns="0" rIns="0" bIns="0" anchor="t">
             <a:spAutoFit/>
           </a:bodyPr>
           <a:lstStyle/>
@@ -10946,6 +11810,7 @@
           <a:lstStyle/>
           <a:p>
             <a:pPr algn="ctr"/>
+            <a:endParaRPr/>
           </a:p>
         </p:txBody>
       </p:sp>
@@ -10990,6 +11855,7 @@
           <a:lstStyle/>
           <a:p>
             <a:pPr algn="ctr"/>
+            <a:endParaRPr/>
           </a:p>
         </p:txBody>
       </p:sp>
@@ -11010,7 +11876,7 @@
           <a:noFill/>
         </p:spPr>
         <p:txBody>
-          <a:bodyPr wrap="square" anchor="t" lIns="0" rIns="0" tIns="0" bIns="0">
+          <a:bodyPr wrap="square" lIns="0" tIns="0" rIns="0" bIns="0" anchor="t">
             <a:spAutoFit/>
           </a:bodyPr>
           <a:lstStyle/>
@@ -11259,6 +12125,7 @@
           <a:lstStyle/>
           <a:p>
             <a:pPr algn="ctr"/>
+            <a:endParaRPr/>
           </a:p>
         </p:txBody>
       </p:sp>
@@ -11303,6 +12170,7 @@
           <a:lstStyle/>
           <a:p>
             <a:pPr algn="ctr"/>
+            <a:endParaRPr/>
           </a:p>
         </p:txBody>
       </p:sp>
@@ -11323,7 +12191,7 @@
           <a:noFill/>
         </p:spPr>
         <p:txBody>
-          <a:bodyPr wrap="square" anchor="ctr" lIns="0" rIns="0" tIns="0" bIns="0">
+          <a:bodyPr wrap="square" lIns="0" tIns="0" rIns="0" bIns="0" anchor="ctr">
             <a:spAutoFit/>
           </a:bodyPr>
           <a:lstStyle/>
@@ -11369,7 +12237,7 @@
 </file>
 
 <file path=ppt/slides/slide3.xml><?xml version="1.0" encoding="utf-8"?>
-<p:sld xmlns:a="http://schemas.openxmlformats.org/drawingml/2006/main" xmlns:p="http://schemas.openxmlformats.org/presentationml/2006/main" xmlns:r="http://schemas.openxmlformats.org/officeDocument/2006/relationships">
+<p:sld xmlns:a="http://schemas.openxmlformats.org/drawingml/2006/main" xmlns:r="http://schemas.openxmlformats.org/officeDocument/2006/relationships" xmlns:p="http://schemas.openxmlformats.org/presentationml/2006/main">
   <p:cSld>
     <p:bg>
       <p:bgPr>
@@ -11385,7 +12253,14 @@
         <p:cNvGrpSpPr/>
         <p:nvPr/>
       </p:nvGrpSpPr>
-      <p:grpSpPr/>
+      <p:grpSpPr>
+        <a:xfrm>
+          <a:off x="0" y="0"/>
+          <a:ext cx="0" cy="0"/>
+          <a:chOff x="0" y="0"/>
+          <a:chExt cx="0" cy="0"/>
+        </a:xfrm>
+      </p:grpSpPr>
       <p:sp>
         <p:nvSpPr>
           <p:cNvPr id="2" name="Rectangle 1"/>
@@ -11427,6 +12302,7 @@
           <a:lstStyle/>
           <a:p>
             <a:pPr algn="ctr"/>
+            <a:endParaRPr/>
           </a:p>
         </p:txBody>
       </p:sp>
@@ -11471,6 +12347,7 @@
           <a:lstStyle/>
           <a:p>
             <a:pPr algn="ctr"/>
+            <a:endParaRPr/>
           </a:p>
         </p:txBody>
       </p:sp>
@@ -11515,6 +12392,7 @@
           <a:lstStyle/>
           <a:p>
             <a:pPr algn="ctr"/>
+            <a:endParaRPr/>
           </a:p>
         </p:txBody>
       </p:sp>
@@ -11535,7 +12413,7 @@
           <a:noFill/>
         </p:spPr>
         <p:txBody>
-          <a:bodyPr wrap="square" anchor="t" lIns="0" rIns="0" tIns="0" bIns="0">
+          <a:bodyPr wrap="square" lIns="0" tIns="0" rIns="0" bIns="0" anchor="t">
             <a:spAutoFit/>
           </a:bodyPr>
           <a:lstStyle/>
@@ -11589,7 +12467,7 @@
           <a:noFill/>
         </p:spPr>
         <p:txBody>
-          <a:bodyPr wrap="square" anchor="t" lIns="0" rIns="0" tIns="0" bIns="0">
+          <a:bodyPr wrap="square" lIns="0" tIns="0" rIns="0" bIns="0" anchor="t">
             <a:spAutoFit/>
           </a:bodyPr>
           <a:lstStyle/>
@@ -11658,6 +12536,7 @@
           <a:lstStyle/>
           <a:p>
             <a:pPr algn="ctr"/>
+            <a:endParaRPr/>
           </a:p>
         </p:txBody>
       </p:sp>
@@ -11678,7 +12557,7 @@
           <a:noFill/>
         </p:spPr>
         <p:txBody>
-          <a:bodyPr wrap="square" anchor="t" lIns="0" rIns="0" tIns="0" bIns="0">
+          <a:bodyPr wrap="square" lIns="0" tIns="0" rIns="0" bIns="0" anchor="t">
             <a:spAutoFit/>
           </a:bodyPr>
           <a:lstStyle/>
@@ -11723,7 +12602,7 @@
           <a:noFill/>
         </p:spPr>
         <p:txBody>
-          <a:bodyPr wrap="square" anchor="t" lIns="0" rIns="0" tIns="0" bIns="0">
+          <a:bodyPr wrap="square" lIns="0" tIns="0" rIns="0" bIns="0" anchor="t">
             <a:spAutoFit/>
           </a:bodyPr>
           <a:lstStyle/>
@@ -11792,6 +12671,7 @@
           <a:lstStyle/>
           <a:p>
             <a:pPr algn="ctr"/>
+            <a:endParaRPr/>
           </a:p>
         </p:txBody>
       </p:sp>
@@ -11836,6 +12716,7 @@
           <a:lstStyle/>
           <a:p>
             <a:pPr algn="ctr"/>
+            <a:endParaRPr/>
           </a:p>
         </p:txBody>
       </p:sp>
@@ -11856,7 +12737,7 @@
           <a:noFill/>
         </p:spPr>
         <p:txBody>
-          <a:bodyPr wrap="square" anchor="t" lIns="0" rIns="0" tIns="0" bIns="0">
+          <a:bodyPr wrap="square" lIns="0" tIns="0" rIns="0" bIns="0" anchor="t">
             <a:spAutoFit/>
           </a:bodyPr>
           <a:lstStyle/>
@@ -11963,6 +12844,7 @@
           <a:lstStyle/>
           <a:p>
             <a:pPr algn="ctr"/>
+            <a:endParaRPr/>
           </a:p>
         </p:txBody>
       </p:sp>
@@ -12007,6 +12889,7 @@
           <a:lstStyle/>
           <a:p>
             <a:pPr algn="ctr"/>
+            <a:endParaRPr/>
           </a:p>
         </p:txBody>
       </p:sp>
@@ -12027,7 +12910,7 @@
           <a:noFill/>
         </p:spPr>
         <p:txBody>
-          <a:bodyPr wrap="square" anchor="t" lIns="0" rIns="0" tIns="0" bIns="0">
+          <a:bodyPr wrap="square" lIns="0" tIns="0" rIns="0" bIns="0" anchor="t">
             <a:spAutoFit/>
           </a:bodyPr>
           <a:lstStyle/>
@@ -12121,6 +13004,7 @@
           <a:lstStyle/>
           <a:p>
             <a:pPr algn="ctr"/>
+            <a:endParaRPr/>
           </a:p>
         </p:txBody>
       </p:sp>
@@ -12165,6 +13049,7 @@
           <a:lstStyle/>
           <a:p>
             <a:pPr algn="ctr"/>
+            <a:endParaRPr/>
           </a:p>
         </p:txBody>
       </p:sp>
@@ -12185,7 +13070,7 @@
           <a:noFill/>
         </p:spPr>
         <p:txBody>
-          <a:bodyPr wrap="square" anchor="t" lIns="0" rIns="0" tIns="0" bIns="0">
+          <a:bodyPr wrap="square" lIns="0" tIns="0" rIns="0" bIns="0" anchor="t">
             <a:spAutoFit/>
           </a:bodyPr>
           <a:lstStyle/>
@@ -12279,6 +13164,7 @@
           <a:lstStyle/>
           <a:p>
             <a:pPr algn="ctr"/>
+            <a:endParaRPr/>
           </a:p>
         </p:txBody>
       </p:sp>
@@ -12323,6 +13209,7 @@
           <a:lstStyle/>
           <a:p>
             <a:pPr algn="ctr"/>
+            <a:endParaRPr/>
           </a:p>
         </p:txBody>
       </p:sp>
@@ -12343,7 +13230,7 @@
           <a:noFill/>
         </p:spPr>
         <p:txBody>
-          <a:bodyPr wrap="square" anchor="t" lIns="0" rIns="0" tIns="0" bIns="0">
+          <a:bodyPr wrap="square" lIns="0" tIns="0" rIns="0" bIns="0" anchor="t">
             <a:spAutoFit/>
           </a:bodyPr>
           <a:lstStyle/>
@@ -12437,6 +13324,7 @@
           <a:lstStyle/>
           <a:p>
             <a:pPr algn="ctr"/>
+            <a:endParaRPr/>
           </a:p>
         </p:txBody>
       </p:sp>
@@ -12481,6 +13369,7 @@
           <a:lstStyle/>
           <a:p>
             <a:pPr algn="ctr"/>
+            <a:endParaRPr/>
           </a:p>
         </p:txBody>
       </p:sp>
@@ -12501,7 +13390,7 @@
           <a:noFill/>
         </p:spPr>
         <p:txBody>
-          <a:bodyPr wrap="square" anchor="t" lIns="0" rIns="0" tIns="0" bIns="0">
+          <a:bodyPr wrap="square" lIns="0" tIns="0" rIns="0" bIns="0" anchor="t">
             <a:spAutoFit/>
           </a:bodyPr>
           <a:lstStyle/>
@@ -12561,7 +13450,7 @@
 </file>
 
 <file path=ppt/slides/slide4.xml><?xml version="1.0" encoding="utf-8"?>
-<p:sld xmlns:a="http://schemas.openxmlformats.org/drawingml/2006/main" xmlns:p="http://schemas.openxmlformats.org/presentationml/2006/main" xmlns:r="http://schemas.openxmlformats.org/officeDocument/2006/relationships">
+<p:sld xmlns:a="http://schemas.openxmlformats.org/drawingml/2006/main" xmlns:r="http://schemas.openxmlformats.org/officeDocument/2006/relationships" xmlns:p="http://schemas.openxmlformats.org/presentationml/2006/main">
   <p:cSld>
     <p:bg>
       <p:bgPr>
@@ -12577,7 +13466,14 @@
         <p:cNvGrpSpPr/>
         <p:nvPr/>
       </p:nvGrpSpPr>
-      <p:grpSpPr/>
+      <p:grpSpPr>
+        <a:xfrm>
+          <a:off x="0" y="0"/>
+          <a:ext cx="0" cy="0"/>
+          <a:chOff x="0" y="0"/>
+          <a:chExt cx="0" cy="0"/>
+        </a:xfrm>
+      </p:grpSpPr>
       <p:sp>
         <p:nvSpPr>
           <p:cNvPr id="2" name="Rectangle 1"/>
@@ -12619,6 +13515,7 @@
           <a:lstStyle/>
           <a:p>
             <a:pPr algn="ctr"/>
+            <a:endParaRPr/>
           </a:p>
         </p:txBody>
       </p:sp>
@@ -12663,6 +13560,7 @@
           <a:lstStyle/>
           <a:p>
             <a:pPr algn="ctr"/>
+            <a:endParaRPr/>
           </a:p>
         </p:txBody>
       </p:sp>
@@ -12707,6 +13605,7 @@
           <a:lstStyle/>
           <a:p>
             <a:pPr algn="ctr"/>
+            <a:endParaRPr/>
           </a:p>
         </p:txBody>
       </p:sp>
@@ -12727,7 +13626,7 @@
           <a:noFill/>
         </p:spPr>
         <p:txBody>
-          <a:bodyPr wrap="square" anchor="t" lIns="0" rIns="0" tIns="0" bIns="0">
+          <a:bodyPr wrap="square" lIns="0" tIns="0" rIns="0" bIns="0" anchor="t">
             <a:spAutoFit/>
           </a:bodyPr>
           <a:lstStyle/>
@@ -12781,7 +13680,7 @@
           <a:noFill/>
         </p:spPr>
         <p:txBody>
-          <a:bodyPr wrap="square" anchor="t" lIns="0" rIns="0" tIns="0" bIns="0">
+          <a:bodyPr wrap="square" lIns="0" tIns="0" rIns="0" bIns="0" anchor="t">
             <a:spAutoFit/>
           </a:bodyPr>
           <a:lstStyle/>
@@ -12850,6 +13749,7 @@
           <a:lstStyle/>
           <a:p>
             <a:pPr algn="ctr"/>
+            <a:endParaRPr/>
           </a:p>
         </p:txBody>
       </p:sp>
@@ -12870,7 +13770,7 @@
           <a:noFill/>
         </p:spPr>
         <p:txBody>
-          <a:bodyPr wrap="square" anchor="t" lIns="0" rIns="0" tIns="0" bIns="0">
+          <a:bodyPr wrap="square" lIns="0" tIns="0" rIns="0" bIns="0" anchor="t">
             <a:spAutoFit/>
           </a:bodyPr>
           <a:lstStyle/>
@@ -12915,7 +13815,7 @@
           <a:noFill/>
         </p:spPr>
         <p:txBody>
-          <a:bodyPr wrap="square" anchor="t" lIns="0" rIns="0" tIns="0" bIns="0">
+          <a:bodyPr wrap="square" lIns="0" tIns="0" rIns="0" bIns="0" anchor="t">
             <a:spAutoFit/>
           </a:bodyPr>
           <a:lstStyle/>
@@ -12984,6 +13884,7 @@
           <a:lstStyle/>
           <a:p>
             <a:pPr algn="ctr"/>
+            <a:endParaRPr/>
           </a:p>
         </p:txBody>
       </p:sp>
@@ -13028,6 +13929,7 @@
           <a:lstStyle/>
           <a:p>
             <a:pPr algn="ctr"/>
+            <a:endParaRPr/>
           </a:p>
         </p:txBody>
       </p:sp>
@@ -13074,6 +13976,7 @@
           <a:lstStyle/>
           <a:p>
             <a:pPr algn="ctr"/>
+            <a:endParaRPr/>
           </a:p>
         </p:txBody>
       </p:sp>
@@ -13118,6 +14021,7 @@
           <a:lstStyle/>
           <a:p>
             <a:pPr algn="ctr"/>
+            <a:endParaRPr/>
           </a:p>
         </p:txBody>
       </p:sp>
@@ -13138,7 +14042,7 @@
           <a:noFill/>
         </p:spPr>
         <p:txBody>
-          <a:bodyPr wrap="square" anchor="ctr" lIns="0" rIns="0" tIns="0" bIns="0">
+          <a:bodyPr wrap="square" lIns="0" tIns="0" rIns="0" bIns="0" anchor="ctr">
             <a:spAutoFit/>
           </a:bodyPr>
           <a:lstStyle/>
@@ -13229,6 +14133,7 @@
           <a:lstStyle/>
           <a:p>
             <a:pPr algn="ctr"/>
+            <a:endParaRPr/>
           </a:p>
         </p:txBody>
       </p:sp>
@@ -13275,6 +14180,7 @@
           <a:lstStyle/>
           <a:p>
             <a:pPr algn="ctr"/>
+            <a:endParaRPr/>
           </a:p>
         </p:txBody>
       </p:sp>
@@ -13319,6 +14225,7 @@
           <a:lstStyle/>
           <a:p>
             <a:pPr algn="ctr"/>
+            <a:endParaRPr/>
           </a:p>
         </p:txBody>
       </p:sp>
@@ -13339,7 +14246,7 @@
           <a:noFill/>
         </p:spPr>
         <p:txBody>
-          <a:bodyPr wrap="square" anchor="ctr" lIns="0" rIns="0" tIns="0" bIns="0">
+          <a:bodyPr wrap="square" lIns="0" tIns="0" rIns="0" bIns="0" anchor="ctr">
             <a:spAutoFit/>
           </a:bodyPr>
           <a:lstStyle/>
@@ -13430,6 +14337,7 @@
           <a:lstStyle/>
           <a:p>
             <a:pPr algn="ctr"/>
+            <a:endParaRPr/>
           </a:p>
         </p:txBody>
       </p:sp>
@@ -13476,6 +14384,7 @@
           <a:lstStyle/>
           <a:p>
             <a:pPr algn="ctr"/>
+            <a:endParaRPr/>
           </a:p>
         </p:txBody>
       </p:sp>
@@ -13520,6 +14429,7 @@
           <a:lstStyle/>
           <a:p>
             <a:pPr algn="ctr"/>
+            <a:endParaRPr/>
           </a:p>
         </p:txBody>
       </p:sp>
@@ -13540,7 +14450,7 @@
           <a:noFill/>
         </p:spPr>
         <p:txBody>
-          <a:bodyPr wrap="square" anchor="ctr" lIns="0" rIns="0" tIns="0" bIns="0">
+          <a:bodyPr wrap="square" lIns="0" tIns="0" rIns="0" bIns="0" anchor="ctr">
             <a:spAutoFit/>
           </a:bodyPr>
           <a:lstStyle/>
@@ -13631,6 +14541,7 @@
           <a:lstStyle/>
           <a:p>
             <a:pPr algn="ctr"/>
+            <a:endParaRPr/>
           </a:p>
         </p:txBody>
       </p:sp>
@@ -13677,6 +14588,7 @@
           <a:lstStyle/>
           <a:p>
             <a:pPr algn="ctr"/>
+            <a:endParaRPr/>
           </a:p>
         </p:txBody>
       </p:sp>
@@ -13721,6 +14633,7 @@
           <a:lstStyle/>
           <a:p>
             <a:pPr algn="ctr"/>
+            <a:endParaRPr/>
           </a:p>
         </p:txBody>
       </p:sp>
@@ -13741,7 +14654,7 @@
           <a:noFill/>
         </p:spPr>
         <p:txBody>
-          <a:bodyPr wrap="square" anchor="ctr" lIns="0" rIns="0" tIns="0" bIns="0">
+          <a:bodyPr wrap="square" lIns="0" tIns="0" rIns="0" bIns="0" anchor="ctr">
             <a:spAutoFit/>
           </a:bodyPr>
           <a:lstStyle/>
@@ -13832,6 +14745,7 @@
           <a:lstStyle/>
           <a:p>
             <a:pPr algn="ctr"/>
+            <a:endParaRPr/>
           </a:p>
         </p:txBody>
       </p:sp>
@@ -13878,6 +14792,7 @@
           <a:lstStyle/>
           <a:p>
             <a:pPr algn="ctr"/>
+            <a:endParaRPr/>
           </a:p>
         </p:txBody>
       </p:sp>
@@ -13922,6 +14837,7 @@
           <a:lstStyle/>
           <a:p>
             <a:pPr algn="ctr"/>
+            <a:endParaRPr/>
           </a:p>
         </p:txBody>
       </p:sp>
@@ -13942,7 +14858,7 @@
           <a:noFill/>
         </p:spPr>
         <p:txBody>
-          <a:bodyPr wrap="square" anchor="ctr" lIns="0" rIns="0" tIns="0" bIns="0">
+          <a:bodyPr wrap="square" lIns="0" tIns="0" rIns="0" bIns="0" anchor="ctr">
             <a:spAutoFit/>
           </a:bodyPr>
           <a:lstStyle/>
@@ -14033,6 +14949,7 @@
           <a:lstStyle/>
           <a:p>
             <a:pPr algn="ctr"/>
+            <a:endParaRPr/>
           </a:p>
         </p:txBody>
       </p:sp>
@@ -14079,6 +14996,7 @@
           <a:lstStyle/>
           <a:p>
             <a:pPr algn="ctr"/>
+            <a:endParaRPr/>
           </a:p>
         </p:txBody>
       </p:sp>
@@ -14123,6 +15041,7 @@
           <a:lstStyle/>
           <a:p>
             <a:pPr algn="ctr"/>
+            <a:endParaRPr/>
           </a:p>
         </p:txBody>
       </p:sp>
@@ -14143,7 +15062,7 @@
           <a:noFill/>
         </p:spPr>
         <p:txBody>
-          <a:bodyPr wrap="square" anchor="ctr" lIns="0" rIns="0" tIns="0" bIns="0">
+          <a:bodyPr wrap="square" lIns="0" tIns="0" rIns="0" bIns="0" anchor="ctr">
             <a:spAutoFit/>
           </a:bodyPr>
           <a:lstStyle/>
@@ -14202,7 +15121,7 @@
 </file>
 
 <file path=ppt/slides/slide5.xml><?xml version="1.0" encoding="utf-8"?>
-<p:sld xmlns:a="http://schemas.openxmlformats.org/drawingml/2006/main" xmlns:p="http://schemas.openxmlformats.org/presentationml/2006/main" xmlns:r="http://schemas.openxmlformats.org/officeDocument/2006/relationships">
+<p:sld xmlns:a="http://schemas.openxmlformats.org/drawingml/2006/main" xmlns:r="http://schemas.openxmlformats.org/officeDocument/2006/relationships" xmlns:p="http://schemas.openxmlformats.org/presentationml/2006/main">
   <p:cSld>
     <p:bg>
       <p:bgPr>
@@ -14218,7 +15137,14 @@
         <p:cNvGrpSpPr/>
         <p:nvPr/>
       </p:nvGrpSpPr>
-      <p:grpSpPr/>
+      <p:grpSpPr>
+        <a:xfrm>
+          <a:off x="0" y="0"/>
+          <a:ext cx="0" cy="0"/>
+          <a:chOff x="0" y="0"/>
+          <a:chExt cx="0" cy="0"/>
+        </a:xfrm>
+      </p:grpSpPr>
       <p:sp>
         <p:nvSpPr>
           <p:cNvPr id="2" name="Rectangle 1"/>
@@ -14260,6 +15186,7 @@
           <a:lstStyle/>
           <a:p>
             <a:pPr algn="ctr"/>
+            <a:endParaRPr/>
           </a:p>
         </p:txBody>
       </p:sp>
@@ -14304,6 +15231,7 @@
           <a:lstStyle/>
           <a:p>
             <a:pPr algn="ctr"/>
+            <a:endParaRPr/>
           </a:p>
         </p:txBody>
       </p:sp>
@@ -14348,6 +15276,7 @@
           <a:lstStyle/>
           <a:p>
             <a:pPr algn="ctr"/>
+            <a:endParaRPr/>
           </a:p>
         </p:txBody>
       </p:sp>
@@ -14368,7 +15297,7 @@
           <a:noFill/>
         </p:spPr>
         <p:txBody>
-          <a:bodyPr wrap="square" anchor="t" lIns="0" rIns="0" tIns="0" bIns="0">
+          <a:bodyPr wrap="square" lIns="0" tIns="0" rIns="0" bIns="0" anchor="t">
             <a:spAutoFit/>
           </a:bodyPr>
           <a:lstStyle/>
@@ -14422,7 +15351,7 @@
           <a:noFill/>
         </p:spPr>
         <p:txBody>
-          <a:bodyPr wrap="square" anchor="t" lIns="0" rIns="0" tIns="0" bIns="0">
+          <a:bodyPr wrap="square" lIns="0" tIns="0" rIns="0" bIns="0" anchor="t">
             <a:spAutoFit/>
           </a:bodyPr>
           <a:lstStyle/>
@@ -14491,6 +15420,7 @@
           <a:lstStyle/>
           <a:p>
             <a:pPr algn="ctr"/>
+            <a:endParaRPr/>
           </a:p>
         </p:txBody>
       </p:sp>
@@ -14511,7 +15441,7 @@
           <a:noFill/>
         </p:spPr>
         <p:txBody>
-          <a:bodyPr wrap="square" anchor="t" lIns="0" rIns="0" tIns="0" bIns="0">
+          <a:bodyPr wrap="square" lIns="0" tIns="0" rIns="0" bIns="0" anchor="t">
             <a:spAutoFit/>
           </a:bodyPr>
           <a:lstStyle/>
@@ -14556,7 +15486,7 @@
           <a:noFill/>
         </p:spPr>
         <p:txBody>
-          <a:bodyPr wrap="square" anchor="t" lIns="0" rIns="0" tIns="0" bIns="0">
+          <a:bodyPr wrap="square" lIns="0" tIns="0" rIns="0" bIns="0" anchor="t">
             <a:spAutoFit/>
           </a:bodyPr>
           <a:lstStyle/>
@@ -14625,6 +15555,7 @@
           <a:lstStyle/>
           <a:p>
             <a:pPr algn="ctr"/>
+            <a:endParaRPr/>
           </a:p>
         </p:txBody>
       </p:sp>
@@ -14669,6 +15600,7 @@
           <a:lstStyle/>
           <a:p>
             <a:pPr algn="ctr"/>
+            <a:endParaRPr/>
           </a:p>
         </p:txBody>
       </p:sp>
@@ -14715,6 +15647,7 @@
           <a:lstStyle/>
           <a:p>
             <a:pPr algn="ctr"/>
+            <a:endParaRPr/>
           </a:p>
         </p:txBody>
       </p:sp>
@@ -14759,6 +15692,7 @@
           <a:lstStyle/>
           <a:p>
             <a:pPr algn="ctr"/>
+            <a:endParaRPr/>
           </a:p>
         </p:txBody>
       </p:sp>
@@ -14779,7 +15713,7 @@
           <a:noFill/>
         </p:spPr>
         <p:txBody>
-          <a:bodyPr wrap="square" anchor="t" lIns="0" rIns="0" tIns="0" bIns="0">
+          <a:bodyPr wrap="square" lIns="0" tIns="0" rIns="0" bIns="0" anchor="t">
             <a:spAutoFit/>
           </a:bodyPr>
           <a:lstStyle/>
@@ -14846,7 +15780,7 @@
           <a:noFill/>
         </p:spPr>
         <p:txBody>
-          <a:bodyPr wrap="square" anchor="t" lIns="0" rIns="0" tIns="0" bIns="0">
+          <a:bodyPr wrap="square" lIns="0" tIns="0" rIns="0" bIns="0" anchor="t">
             <a:spAutoFit/>
           </a:bodyPr>
           <a:lstStyle/>
@@ -14918,6 +15852,7 @@
           <a:lstStyle/>
           <a:p>
             <a:pPr algn="ctr"/>
+            <a:endParaRPr/>
           </a:p>
         </p:txBody>
       </p:sp>
@@ -14962,6 +15897,7 @@
           <a:lstStyle/>
           <a:p>
             <a:pPr algn="ctr"/>
+            <a:endParaRPr/>
           </a:p>
         </p:txBody>
       </p:sp>
@@ -14982,7 +15918,7 @@
           <a:noFill/>
         </p:spPr>
         <p:txBody>
-          <a:bodyPr wrap="square" anchor="t" lIns="0" rIns="0" tIns="0" bIns="0">
+          <a:bodyPr wrap="square" lIns="0" tIns="0" rIns="0" bIns="0" anchor="t">
             <a:spAutoFit/>
           </a:bodyPr>
           <a:lstStyle/>
@@ -15049,7 +15985,7 @@
           <a:noFill/>
         </p:spPr>
         <p:txBody>
-          <a:bodyPr wrap="square" anchor="t" lIns="0" rIns="0" tIns="0" bIns="0">
+          <a:bodyPr wrap="square" lIns="0" tIns="0" rIns="0" bIns="0" anchor="t">
             <a:spAutoFit/>
           </a:bodyPr>
           <a:lstStyle/>
@@ -15121,6 +16057,7 @@
           <a:lstStyle/>
           <a:p>
             <a:pPr algn="ctr"/>
+            <a:endParaRPr/>
           </a:p>
         </p:txBody>
       </p:sp>
@@ -15165,6 +16102,7 @@
           <a:lstStyle/>
           <a:p>
             <a:pPr algn="ctr"/>
+            <a:endParaRPr/>
           </a:p>
         </p:txBody>
       </p:sp>
@@ -15185,7 +16123,7 @@
           <a:noFill/>
         </p:spPr>
         <p:txBody>
-          <a:bodyPr wrap="square" anchor="t" lIns="0" rIns="0" tIns="0" bIns="0">
+          <a:bodyPr wrap="square" lIns="0" tIns="0" rIns="0" bIns="0" anchor="t">
             <a:spAutoFit/>
           </a:bodyPr>
           <a:lstStyle/>
@@ -15252,7 +16190,7 @@
           <a:noFill/>
         </p:spPr>
         <p:txBody>
-          <a:bodyPr wrap="square" anchor="t" lIns="0" rIns="0" tIns="0" bIns="0">
+          <a:bodyPr wrap="square" lIns="0" tIns="0" rIns="0" bIns="0" anchor="t">
             <a:spAutoFit/>
           </a:bodyPr>
           <a:lstStyle/>
@@ -15290,7 +16228,7 @@
 </file>
 
 <file path=ppt/slides/slide6.xml><?xml version="1.0" encoding="utf-8"?>
-<p:sld xmlns:a="http://schemas.openxmlformats.org/drawingml/2006/main" xmlns:p="http://schemas.openxmlformats.org/presentationml/2006/main" xmlns:r="http://schemas.openxmlformats.org/officeDocument/2006/relationships">
+<p:sld xmlns:a="http://schemas.openxmlformats.org/drawingml/2006/main" xmlns:r="http://schemas.openxmlformats.org/officeDocument/2006/relationships" xmlns:p="http://schemas.openxmlformats.org/presentationml/2006/main">
   <p:cSld>
     <p:bg>
       <p:bgPr>
@@ -15306,7 +16244,14 @@
         <p:cNvGrpSpPr/>
         <p:nvPr/>
       </p:nvGrpSpPr>
-      <p:grpSpPr/>
+      <p:grpSpPr>
+        <a:xfrm>
+          <a:off x="0" y="0"/>
+          <a:ext cx="0" cy="0"/>
+          <a:chOff x="0" y="0"/>
+          <a:chExt cx="0" cy="0"/>
+        </a:xfrm>
+      </p:grpSpPr>
       <p:sp>
         <p:nvSpPr>
           <p:cNvPr id="2" name="Rectangle 1"/>
@@ -15348,6 +16293,7 @@
           <a:lstStyle/>
           <a:p>
             <a:pPr algn="ctr"/>
+            <a:endParaRPr/>
           </a:p>
         </p:txBody>
       </p:sp>
@@ -15392,6 +16338,7 @@
           <a:lstStyle/>
           <a:p>
             <a:pPr algn="ctr"/>
+            <a:endParaRPr/>
           </a:p>
         </p:txBody>
       </p:sp>
@@ -15436,6 +16383,7 @@
           <a:lstStyle/>
           <a:p>
             <a:pPr algn="ctr"/>
+            <a:endParaRPr/>
           </a:p>
         </p:txBody>
       </p:sp>
@@ -15456,7 +16404,7 @@
           <a:noFill/>
         </p:spPr>
         <p:txBody>
-          <a:bodyPr wrap="square" anchor="t" lIns="0" rIns="0" tIns="0" bIns="0">
+          <a:bodyPr wrap="square" lIns="0" tIns="0" rIns="0" bIns="0" anchor="t">
             <a:spAutoFit/>
           </a:bodyPr>
           <a:lstStyle/>
@@ -15510,7 +16458,7 @@
           <a:noFill/>
         </p:spPr>
         <p:txBody>
-          <a:bodyPr wrap="square" anchor="t" lIns="0" rIns="0" tIns="0" bIns="0">
+          <a:bodyPr wrap="square" lIns="0" tIns="0" rIns="0" bIns="0" anchor="t">
             <a:spAutoFit/>
           </a:bodyPr>
           <a:lstStyle/>
@@ -15579,6 +16527,7 @@
           <a:lstStyle/>
           <a:p>
             <a:pPr algn="ctr"/>
+            <a:endParaRPr/>
           </a:p>
         </p:txBody>
       </p:sp>
@@ -15599,7 +16548,7 @@
           <a:noFill/>
         </p:spPr>
         <p:txBody>
-          <a:bodyPr wrap="square" anchor="t" lIns="0" rIns="0" tIns="0" bIns="0">
+          <a:bodyPr wrap="square" lIns="0" tIns="0" rIns="0" bIns="0" anchor="t">
             <a:spAutoFit/>
           </a:bodyPr>
           <a:lstStyle/>
@@ -15644,7 +16593,7 @@
           <a:noFill/>
         </p:spPr>
         <p:txBody>
-          <a:bodyPr wrap="square" anchor="t" lIns="0" rIns="0" tIns="0" bIns="0">
+          <a:bodyPr wrap="square" lIns="0" tIns="0" rIns="0" bIns="0" anchor="t">
             <a:spAutoFit/>
           </a:bodyPr>
           <a:lstStyle/>
@@ -15713,6 +16662,7 @@
           <a:lstStyle/>
           <a:p>
             <a:pPr algn="ctr"/>
+            <a:endParaRPr/>
           </a:p>
         </p:txBody>
       </p:sp>
@@ -15757,6 +16707,7 @@
           <a:lstStyle/>
           <a:p>
             <a:pPr algn="ctr"/>
+            <a:endParaRPr/>
           </a:p>
         </p:txBody>
       </p:sp>
@@ -15779,10 +16730,34 @@
                 <a:tableStyleId>{5C22544A-7EE6-4342-B048-85BDC9FD1C3A}</a:tableStyleId>
               </a:tblPr>
               <a:tblGrid>
-                <a:gridCol w="1828800"/>
-                <a:gridCol w="3108960"/>
-                <a:gridCol w="1554480"/>
-                <a:gridCol w="4023360"/>
+                <a:gridCol w="1828800">
+                  <a:extLst>
+                    <a:ext uri="{9D8B030D-6E8A-4147-A177-3AD203B41FA5}">
+                      <a16:colId xmlns:a16="http://schemas.microsoft.com/office/drawing/2014/main" val="20000"/>
+                    </a:ext>
+                  </a:extLst>
+                </a:gridCol>
+                <a:gridCol w="3108960">
+                  <a:extLst>
+                    <a:ext uri="{9D8B030D-6E8A-4147-A177-3AD203B41FA5}">
+                      <a16:colId xmlns:a16="http://schemas.microsoft.com/office/drawing/2014/main" val="20001"/>
+                    </a:ext>
+                  </a:extLst>
+                </a:gridCol>
+                <a:gridCol w="1554480">
+                  <a:extLst>
+                    <a:ext uri="{9D8B030D-6E8A-4147-A177-3AD203B41FA5}">
+                      <a16:colId xmlns:a16="http://schemas.microsoft.com/office/drawing/2014/main" val="20002"/>
+                    </a:ext>
+                  </a:extLst>
+                </a:gridCol>
+                <a:gridCol w="4023360">
+                  <a:extLst>
+                    <a:ext uri="{9D8B030D-6E8A-4147-A177-3AD203B41FA5}">
+                      <a16:colId xmlns:a16="http://schemas.microsoft.com/office/drawing/2014/main" val="20003"/>
+                    </a:ext>
+                  </a:extLst>
+                </a:gridCol>
               </a:tblGrid>
               <a:tr h="457200">
                 <a:tc>
@@ -15877,6 +16852,11 @@
                     </a:solidFill>
                   </a:tcPr>
                 </a:tc>
+                <a:extLst>
+                  <a:ext uri="{0D108BD9-81ED-4DB2-BD59-A6C34878D82A}">
+                    <a16:rowId xmlns:a16="http://schemas.microsoft.com/office/drawing/2014/main" val="10000"/>
+                  </a:ext>
+                </a:extLst>
               </a:tr>
               <a:tr h="548640">
                 <a:tc>
@@ -15971,6 +16951,11 @@
                     </a:solidFill>
                   </a:tcPr>
                 </a:tc>
+                <a:extLst>
+                  <a:ext uri="{0D108BD9-81ED-4DB2-BD59-A6C34878D82A}">
+                    <a16:rowId xmlns:a16="http://schemas.microsoft.com/office/drawing/2014/main" val="10001"/>
+                  </a:ext>
+                </a:extLst>
               </a:tr>
               <a:tr h="548640">
                 <a:tc>
@@ -16065,6 +17050,11 @@
                     </a:solidFill>
                   </a:tcPr>
                 </a:tc>
+                <a:extLst>
+                  <a:ext uri="{0D108BD9-81ED-4DB2-BD59-A6C34878D82A}">
+                    <a16:rowId xmlns:a16="http://schemas.microsoft.com/office/drawing/2014/main" val="10002"/>
+                  </a:ext>
+                </a:extLst>
               </a:tr>
               <a:tr h="548640">
                 <a:tc>
@@ -16159,6 +17149,11 @@
                     </a:solidFill>
                   </a:tcPr>
                 </a:tc>
+                <a:extLst>
+                  <a:ext uri="{0D108BD9-81ED-4DB2-BD59-A6C34878D82A}">
+                    <a16:rowId xmlns:a16="http://schemas.microsoft.com/office/drawing/2014/main" val="10003"/>
+                  </a:ext>
+                </a:extLst>
               </a:tr>
               <a:tr h="548640">
                 <a:tc>
@@ -16253,6 +17248,11 @@
                     </a:solidFill>
                   </a:tcPr>
                 </a:tc>
+                <a:extLst>
+                  <a:ext uri="{0D108BD9-81ED-4DB2-BD59-A6C34878D82A}">
+                    <a16:rowId xmlns:a16="http://schemas.microsoft.com/office/drawing/2014/main" val="10004"/>
+                  </a:ext>
+                </a:extLst>
               </a:tr>
               <a:tr h="548640">
                 <a:tc>
@@ -16347,6 +17347,11 @@
                     </a:solidFill>
                   </a:tcPr>
                 </a:tc>
+                <a:extLst>
+                  <a:ext uri="{0D108BD9-81ED-4DB2-BD59-A6C34878D82A}">
+                    <a16:rowId xmlns:a16="http://schemas.microsoft.com/office/drawing/2014/main" val="10005"/>
+                  </a:ext>
+                </a:extLst>
               </a:tr>
             </a:tbl>
           </a:graphicData>
@@ -16369,7 +17374,7 @@
           <a:noFill/>
         </p:spPr>
         <p:txBody>
-          <a:bodyPr wrap="square" anchor="t" lIns="0" rIns="0" tIns="0" bIns="0">
+          <a:bodyPr wrap="square" lIns="0" tIns="0" rIns="0" bIns="0" anchor="t">
             <a:spAutoFit/>
           </a:bodyPr>
           <a:lstStyle/>
@@ -16415,7 +17420,7 @@
 </file>
 
 <file path=ppt/slides/slide7.xml><?xml version="1.0" encoding="utf-8"?>
-<p:sld xmlns:a="http://schemas.openxmlformats.org/drawingml/2006/main" xmlns:p="http://schemas.openxmlformats.org/presentationml/2006/main" xmlns:r="http://schemas.openxmlformats.org/officeDocument/2006/relationships">
+<p:sld xmlns:a="http://schemas.openxmlformats.org/drawingml/2006/main" xmlns:r="http://schemas.openxmlformats.org/officeDocument/2006/relationships" xmlns:p="http://schemas.openxmlformats.org/presentationml/2006/main">
   <p:cSld>
     <p:bg>
       <p:bgPr>
@@ -16431,7 +17436,14 @@
         <p:cNvGrpSpPr/>
         <p:nvPr/>
       </p:nvGrpSpPr>
-      <p:grpSpPr/>
+      <p:grpSpPr>
+        <a:xfrm>
+          <a:off x="0" y="0"/>
+          <a:ext cx="0" cy="0"/>
+          <a:chOff x="0" y="0"/>
+          <a:chExt cx="0" cy="0"/>
+        </a:xfrm>
+      </p:grpSpPr>
       <p:sp>
         <p:nvSpPr>
           <p:cNvPr id="2" name="Rectangle 1"/>
@@ -16473,6 +17485,7 @@
           <a:lstStyle/>
           <a:p>
             <a:pPr algn="ctr"/>
+            <a:endParaRPr/>
           </a:p>
         </p:txBody>
       </p:sp>
@@ -16517,6 +17530,7 @@
           <a:lstStyle/>
           <a:p>
             <a:pPr algn="ctr"/>
+            <a:endParaRPr/>
           </a:p>
         </p:txBody>
       </p:sp>
@@ -16561,6 +17575,7 @@
           <a:lstStyle/>
           <a:p>
             <a:pPr algn="ctr"/>
+            <a:endParaRPr/>
           </a:p>
         </p:txBody>
       </p:sp>
@@ -16581,7 +17596,7 @@
           <a:noFill/>
         </p:spPr>
         <p:txBody>
-          <a:bodyPr wrap="square" anchor="t" lIns="0" rIns="0" tIns="0" bIns="0">
+          <a:bodyPr wrap="square" lIns="0" tIns="0" rIns="0" bIns="0" anchor="t">
             <a:spAutoFit/>
           </a:bodyPr>
           <a:lstStyle/>
@@ -16635,7 +17650,7 @@
           <a:noFill/>
         </p:spPr>
         <p:txBody>
-          <a:bodyPr wrap="square" anchor="t" lIns="0" rIns="0" tIns="0" bIns="0">
+          <a:bodyPr wrap="square" lIns="0" tIns="0" rIns="0" bIns="0" anchor="t">
             <a:spAutoFit/>
           </a:bodyPr>
           <a:lstStyle/>
@@ -16704,6 +17719,7 @@
           <a:lstStyle/>
           <a:p>
             <a:pPr algn="ctr"/>
+            <a:endParaRPr/>
           </a:p>
         </p:txBody>
       </p:sp>
@@ -16724,7 +17740,7 @@
           <a:noFill/>
         </p:spPr>
         <p:txBody>
-          <a:bodyPr wrap="square" anchor="t" lIns="0" rIns="0" tIns="0" bIns="0">
+          <a:bodyPr wrap="square" lIns="0" tIns="0" rIns="0" bIns="0" anchor="t">
             <a:spAutoFit/>
           </a:bodyPr>
           <a:lstStyle/>
@@ -16769,7 +17785,7 @@
           <a:noFill/>
         </p:spPr>
         <p:txBody>
-          <a:bodyPr wrap="square" anchor="t" lIns="0" rIns="0" tIns="0" bIns="0">
+          <a:bodyPr wrap="square" lIns="0" tIns="0" rIns="0" bIns="0" anchor="t">
             <a:spAutoFit/>
           </a:bodyPr>
           <a:lstStyle/>
@@ -16838,6 +17854,7 @@
           <a:lstStyle/>
           <a:p>
             <a:pPr algn="ctr"/>
+            <a:endParaRPr/>
           </a:p>
         </p:txBody>
       </p:sp>
@@ -16882,6 +17899,7 @@
           <a:lstStyle/>
           <a:p>
             <a:pPr algn="ctr"/>
+            <a:endParaRPr/>
           </a:p>
         </p:txBody>
       </p:sp>
@@ -16928,6 +17946,7 @@
           <a:lstStyle/>
           <a:p>
             <a:pPr algn="ctr"/>
+            <a:endParaRPr/>
           </a:p>
         </p:txBody>
       </p:sp>
@@ -16972,6 +17991,7 @@
           <a:lstStyle/>
           <a:p>
             <a:pPr algn="ctr"/>
+            <a:endParaRPr/>
           </a:p>
         </p:txBody>
       </p:sp>
@@ -16992,7 +18012,7 @@
           <a:noFill/>
         </p:spPr>
         <p:txBody>
-          <a:bodyPr wrap="square" anchor="t" lIns="0" rIns="0" tIns="0" bIns="0">
+          <a:bodyPr wrap="square" lIns="0" tIns="0" rIns="0" bIns="0" anchor="t">
             <a:spAutoFit/>
           </a:bodyPr>
           <a:lstStyle/>
@@ -17037,7 +18057,7 @@
           <a:noFill/>
         </p:spPr>
         <p:txBody>
-          <a:bodyPr wrap="square" anchor="t" lIns="0" rIns="0" tIns="0" bIns="0">
+          <a:bodyPr wrap="square" lIns="0" tIns="0" rIns="0" bIns="0" anchor="t">
             <a:spAutoFit/>
           </a:bodyPr>
           <a:lstStyle/>
@@ -17210,6 +18230,7 @@
           <a:lstStyle/>
           <a:p>
             <a:pPr algn="ctr"/>
+            <a:endParaRPr/>
           </a:p>
         </p:txBody>
       </p:sp>
@@ -17254,6 +18275,7 @@
           <a:lstStyle/>
           <a:p>
             <a:pPr algn="ctr"/>
+            <a:endParaRPr/>
           </a:p>
         </p:txBody>
       </p:sp>
@@ -17274,7 +18296,7 @@
           <a:noFill/>
         </p:spPr>
         <p:txBody>
-          <a:bodyPr wrap="square" anchor="t" lIns="0" rIns="0" tIns="0" bIns="0">
+          <a:bodyPr wrap="square" lIns="0" tIns="0" rIns="0" bIns="0" anchor="t">
             <a:spAutoFit/>
           </a:bodyPr>
           <a:lstStyle/>
@@ -17319,7 +18341,7 @@
           <a:noFill/>
         </p:spPr>
         <p:txBody>
-          <a:bodyPr wrap="square" anchor="t" lIns="0" rIns="0" tIns="0" bIns="0">
+          <a:bodyPr wrap="square" lIns="0" tIns="0" rIns="0" bIns="0" anchor="t">
             <a:spAutoFit/>
           </a:bodyPr>
           <a:lstStyle/>
@@ -17492,6 +18514,7 @@
           <a:lstStyle/>
           <a:p>
             <a:pPr algn="ctr"/>
+            <a:endParaRPr/>
           </a:p>
         </p:txBody>
       </p:sp>
@@ -17512,7 +18535,7 @@
           <a:noFill/>
         </p:spPr>
         <p:txBody>
-          <a:bodyPr wrap="square" anchor="ctr" lIns="0" rIns="0" tIns="0" bIns="0">
+          <a:bodyPr wrap="square" lIns="0" tIns="0" rIns="0" bIns="0" anchor="ctr">
             <a:spAutoFit/>
           </a:bodyPr>
           <a:lstStyle/>
@@ -17558,7 +18581,7 @@
 </file>
 
 <file path=ppt/slides/slide8.xml><?xml version="1.0" encoding="utf-8"?>
-<p:sld xmlns:a="http://schemas.openxmlformats.org/drawingml/2006/main" xmlns:p="http://schemas.openxmlformats.org/presentationml/2006/main" xmlns:r="http://schemas.openxmlformats.org/officeDocument/2006/relationships">
+<p:sld xmlns:a="http://schemas.openxmlformats.org/drawingml/2006/main" xmlns:r="http://schemas.openxmlformats.org/officeDocument/2006/relationships" xmlns:p="http://schemas.openxmlformats.org/presentationml/2006/main">
   <p:cSld>
     <p:bg>
       <p:bgPr>
@@ -17574,7 +18597,14 @@
         <p:cNvGrpSpPr/>
         <p:nvPr/>
       </p:nvGrpSpPr>
-      <p:grpSpPr/>
+      <p:grpSpPr>
+        <a:xfrm>
+          <a:off x="0" y="0"/>
+          <a:ext cx="0" cy="0"/>
+          <a:chOff x="0" y="0"/>
+          <a:chExt cx="0" cy="0"/>
+        </a:xfrm>
+      </p:grpSpPr>
       <p:sp>
         <p:nvSpPr>
           <p:cNvPr id="2" name="Rectangle 1"/>
@@ -17616,6 +18646,7 @@
           <a:lstStyle/>
           <a:p>
             <a:pPr algn="ctr"/>
+            <a:endParaRPr/>
           </a:p>
         </p:txBody>
       </p:sp>
@@ -17660,6 +18691,7 @@
           <a:lstStyle/>
           <a:p>
             <a:pPr algn="ctr"/>
+            <a:endParaRPr/>
           </a:p>
         </p:txBody>
       </p:sp>
@@ -17704,6 +18736,7 @@
           <a:lstStyle/>
           <a:p>
             <a:pPr algn="ctr"/>
+            <a:endParaRPr/>
           </a:p>
         </p:txBody>
       </p:sp>
@@ -17724,7 +18757,7 @@
           <a:noFill/>
         </p:spPr>
         <p:txBody>
-          <a:bodyPr wrap="square" anchor="t" lIns="0" rIns="0" tIns="0" bIns="0">
+          <a:bodyPr wrap="square" lIns="0" tIns="0" rIns="0" bIns="0" anchor="t">
             <a:spAutoFit/>
           </a:bodyPr>
           <a:lstStyle/>
@@ -17778,7 +18811,7 @@
           <a:noFill/>
         </p:spPr>
         <p:txBody>
-          <a:bodyPr wrap="square" anchor="t" lIns="0" rIns="0" tIns="0" bIns="0">
+          <a:bodyPr wrap="square" lIns="0" tIns="0" rIns="0" bIns="0" anchor="t">
             <a:spAutoFit/>
           </a:bodyPr>
           <a:lstStyle/>
@@ -17847,6 +18880,7 @@
           <a:lstStyle/>
           <a:p>
             <a:pPr algn="ctr"/>
+            <a:endParaRPr/>
           </a:p>
         </p:txBody>
       </p:sp>
@@ -17867,7 +18901,7 @@
           <a:noFill/>
         </p:spPr>
         <p:txBody>
-          <a:bodyPr wrap="square" anchor="t" lIns="0" rIns="0" tIns="0" bIns="0">
+          <a:bodyPr wrap="square" lIns="0" tIns="0" rIns="0" bIns="0" anchor="t">
             <a:spAutoFit/>
           </a:bodyPr>
           <a:lstStyle/>
@@ -17912,7 +18946,7 @@
           <a:noFill/>
         </p:spPr>
         <p:txBody>
-          <a:bodyPr wrap="square" anchor="t" lIns="0" rIns="0" tIns="0" bIns="0">
+          <a:bodyPr wrap="square" lIns="0" tIns="0" rIns="0" bIns="0" anchor="t">
             <a:spAutoFit/>
           </a:bodyPr>
           <a:lstStyle/>
@@ -17981,6 +19015,7 @@
           <a:lstStyle/>
           <a:p>
             <a:pPr algn="ctr"/>
+            <a:endParaRPr/>
           </a:p>
         </p:txBody>
       </p:sp>
@@ -18025,6 +19060,7 @@
           <a:lstStyle/>
           <a:p>
             <a:pPr algn="ctr"/>
+            <a:endParaRPr/>
           </a:p>
         </p:txBody>
       </p:sp>
@@ -18045,7 +19081,7 @@
           <a:noFill/>
         </p:spPr>
         <p:txBody>
-          <a:bodyPr wrap="square" anchor="t" lIns="0" rIns="0" tIns="0" bIns="0">
+          <a:bodyPr wrap="square" lIns="0" tIns="0" rIns="0" bIns="0" anchor="t">
             <a:spAutoFit/>
           </a:bodyPr>
           <a:lstStyle/>
@@ -18260,7 +19296,7 @@
 </file>
 
 <file path=ppt/slides/slide9.xml><?xml version="1.0" encoding="utf-8"?>
-<p:sld xmlns:a="http://schemas.openxmlformats.org/drawingml/2006/main" xmlns:p="http://schemas.openxmlformats.org/presentationml/2006/main" xmlns:r="http://schemas.openxmlformats.org/officeDocument/2006/relationships">
+<p:sld xmlns:a="http://schemas.openxmlformats.org/drawingml/2006/main" xmlns:r="http://schemas.openxmlformats.org/officeDocument/2006/relationships" xmlns:p="http://schemas.openxmlformats.org/presentationml/2006/main">
   <p:cSld>
     <p:bg>
       <p:bgPr>
@@ -18276,7 +19312,14 @@
         <p:cNvGrpSpPr/>
         <p:nvPr/>
       </p:nvGrpSpPr>
-      <p:grpSpPr/>
+      <p:grpSpPr>
+        <a:xfrm>
+          <a:off x="0" y="0"/>
+          <a:ext cx="0" cy="0"/>
+          <a:chOff x="0" y="0"/>
+          <a:chExt cx="0" cy="0"/>
+        </a:xfrm>
+      </p:grpSpPr>
       <p:sp>
         <p:nvSpPr>
           <p:cNvPr id="2" name="Rectangle 1"/>
@@ -18318,6 +19361,7 @@
           <a:lstStyle/>
           <a:p>
             <a:pPr algn="ctr"/>
+            <a:endParaRPr/>
           </a:p>
         </p:txBody>
       </p:sp>
@@ -18362,6 +19406,7 @@
           <a:lstStyle/>
           <a:p>
             <a:pPr algn="ctr"/>
+            <a:endParaRPr/>
           </a:p>
         </p:txBody>
       </p:sp>
@@ -18406,6 +19451,7 @@
           <a:lstStyle/>
           <a:p>
             <a:pPr algn="ctr"/>
+            <a:endParaRPr/>
           </a:p>
         </p:txBody>
       </p:sp>
@@ -18426,7 +19472,7 @@
           <a:noFill/>
         </p:spPr>
         <p:txBody>
-          <a:bodyPr wrap="square" anchor="t" lIns="0" rIns="0" tIns="0" bIns="0">
+          <a:bodyPr wrap="square" lIns="0" tIns="0" rIns="0" bIns="0" anchor="t">
             <a:spAutoFit/>
           </a:bodyPr>
           <a:lstStyle/>
@@ -18480,7 +19526,7 @@
           <a:noFill/>
         </p:spPr>
         <p:txBody>
-          <a:bodyPr wrap="square" anchor="t" lIns="0" rIns="0" tIns="0" bIns="0">
+          <a:bodyPr wrap="square" lIns="0" tIns="0" rIns="0" bIns="0" anchor="t">
             <a:spAutoFit/>
           </a:bodyPr>
           <a:lstStyle/>
@@ -18549,6 +19595,7 @@
           <a:lstStyle/>
           <a:p>
             <a:pPr algn="ctr"/>
+            <a:endParaRPr/>
           </a:p>
         </p:txBody>
       </p:sp>
@@ -18569,7 +19616,7 @@
           <a:noFill/>
         </p:spPr>
         <p:txBody>
-          <a:bodyPr wrap="square" anchor="t" lIns="0" rIns="0" tIns="0" bIns="0">
+          <a:bodyPr wrap="square" lIns="0" tIns="0" rIns="0" bIns="0" anchor="t">
             <a:spAutoFit/>
           </a:bodyPr>
           <a:lstStyle/>
@@ -18614,7 +19661,7 @@
           <a:noFill/>
         </p:spPr>
         <p:txBody>
-          <a:bodyPr wrap="square" anchor="t" lIns="0" rIns="0" tIns="0" bIns="0">
+          <a:bodyPr wrap="square" lIns="0" tIns="0" rIns="0" bIns="0" anchor="t">
             <a:spAutoFit/>
           </a:bodyPr>
           <a:lstStyle/>
@@ -18683,6 +19730,7 @@
           <a:lstStyle/>
           <a:p>
             <a:pPr algn="ctr"/>
+            <a:endParaRPr/>
           </a:p>
         </p:txBody>
       </p:sp>
@@ -18727,6 +19775,7 @@
           <a:lstStyle/>
           <a:p>
             <a:pPr algn="ctr"/>
+            <a:endParaRPr/>
           </a:p>
         </p:txBody>
       </p:sp>
@@ -18773,6 +19822,7 @@
           <a:lstStyle/>
           <a:p>
             <a:pPr algn="ctr"/>
+            <a:endParaRPr/>
           </a:p>
         </p:txBody>
       </p:sp>
@@ -18817,6 +19867,7 @@
           <a:lstStyle/>
           <a:p>
             <a:pPr algn="ctr"/>
+            <a:endParaRPr/>
           </a:p>
         </p:txBody>
       </p:sp>
@@ -18837,7 +19888,7 @@
           <a:noFill/>
         </p:spPr>
         <p:txBody>
-          <a:bodyPr wrap="square" anchor="t" lIns="0" rIns="0" tIns="0" bIns="0">
+          <a:bodyPr wrap="square" lIns="0" tIns="0" rIns="0" bIns="0" anchor="t">
             <a:spAutoFit/>
           </a:bodyPr>
           <a:lstStyle/>
@@ -18882,7 +19933,7 @@
           <a:noFill/>
         </p:spPr>
         <p:txBody>
-          <a:bodyPr wrap="square" anchor="t" lIns="0" rIns="0" tIns="0" bIns="0">
+          <a:bodyPr wrap="square" lIns="0" tIns="0" rIns="0" bIns="0" anchor="t">
             <a:spAutoFit/>
           </a:bodyPr>
           <a:lstStyle/>
@@ -19024,6 +20075,7 @@
           <a:lstStyle/>
           <a:p>
             <a:pPr algn="ctr"/>
+            <a:endParaRPr/>
           </a:p>
         </p:txBody>
       </p:sp>
@@ -19068,6 +20120,7 @@
           <a:lstStyle/>
           <a:p>
             <a:pPr algn="ctr"/>
+            <a:endParaRPr/>
           </a:p>
         </p:txBody>
       </p:sp>
@@ -19088,7 +20141,7 @@
           <a:noFill/>
         </p:spPr>
         <p:txBody>
-          <a:bodyPr wrap="square" anchor="t" lIns="0" rIns="0" tIns="0" bIns="0">
+          <a:bodyPr wrap="square" lIns="0" tIns="0" rIns="0" bIns="0" anchor="t">
             <a:spAutoFit/>
           </a:bodyPr>
           <a:lstStyle/>
@@ -19133,7 +20186,7 @@
           <a:noFill/>
         </p:spPr>
         <p:txBody>
-          <a:bodyPr wrap="square" anchor="t" lIns="0" rIns="0" tIns="0" bIns="0">
+          <a:bodyPr wrap="square" lIns="0" tIns="0" rIns="0" bIns="0" anchor="t">
             <a:spAutoFit/>
           </a:bodyPr>
           <a:lstStyle/>
@@ -19280,7 +20333,7 @@
           <a:noFill/>
         </p:spPr>
         <p:txBody>
-          <a:bodyPr wrap="square" anchor="t" lIns="0" rIns="0" tIns="0" bIns="0">
+          <a:bodyPr wrap="square" lIns="0" tIns="0" rIns="0" bIns="0" anchor="t">
             <a:spAutoFit/>
           </a:bodyPr>
           <a:lstStyle/>

</xml_diff>